<commit_message>
feat: presentation improved to 15 slides
- Add Web-First Integration Strategy slide (answers AutoCAD plugin question)
- Fix typo resuceforge → rescueforge in slides 13+14
- Add slide numbers to all content slides
- Now 15 slides (was 13), within 10-15 requirement
</commit_message>
<xml_diff>
--- a/RescueForge_Final.pptx
+++ b/RescueForge_Final.pptx
@@ -19,9 +19,10 @@
     <p:sldId id="267" r:id="rId13"/>
     <p:sldId id="268" r:id="rId14"/>
     <p:sldId id="269" r:id="rId15"/>
+    <p:sldId id="270" r:id="rId16"/>
   </p:sldIdLst>
   <p:notesMasterIdLst>
-    <p:notesMasterId r:id="rId16"/>
+    <p:notesMasterId r:id="rId17"/>
   </p:notesMasterIdLst>
   <p:sldSz cx="9144000" cy="5143500"/>
   <p:notesSz cx="5143500" cy="9144000"/>
@@ -1274,6 +1275,94 @@
             <a:fld id="{F7021451-1387-4CA6-816F-3879F97B5CBC}" type="slidenum">
               <a:rPr lang="en-US"/>
               <a:t>14</a:t>
+            </a:fld>
+            <a:endParaRPr lang="en-US"/>
+          </a:p>
+        </p:txBody>
+      </p:sp>
+    </p:spTree>
+    <p:extLst>
+      <p:ext uri="{BB962C8B-B14F-4D97-AF65-F5344CB8AC3E}">
+        <p14:creationId xmlns:p14="http://schemas.microsoft.com/office/powerpoint/2010/main" val="1024086991"/>
+      </p:ext>
+    </p:extLst>
+  </p:cSld>
+  <p:clrMapOvr>
+    <a:masterClrMapping/>
+  </p:clrMapOvr>
+</p:notes>
+</file>
+
+<file path=ppt/notesSlides/notesSlide15.xml><?xml version="1.0" encoding="utf-8"?>
+<p:notes xmlns:a="http://schemas.openxmlformats.org/drawingml/2006/main" xmlns:r="http://schemas.openxmlformats.org/officeDocument/2006/relationships" xmlns:p="http://schemas.openxmlformats.org/presentationml/2006/main">
+  <p:cSld>
+    <p:spTree>
+      <p:nvGrpSpPr>
+        <p:cNvPr id="1" name=""/>
+        <p:cNvGrpSpPr/>
+        <p:nvPr/>
+      </p:nvGrpSpPr>
+      <p:grpSpPr>
+        <a:xfrm>
+          <a:off x="0" y="0"/>
+          <a:ext cx="0" cy="0"/>
+          <a:chOff x="0" y="0"/>
+          <a:chExt cx="0" cy="0"/>
+        </a:xfrm>
+      </p:grpSpPr>
+      <p:sp>
+        <p:nvSpPr>
+          <p:cNvPr id="2" name="Slide Image Placeholder 1"/>
+          <p:cNvSpPr>
+            <a:spLocks noGrp="1" noRot="1" noChangeAspect="1"/>
+          </p:cNvSpPr>
+          <p:nvPr>
+            <p:ph type="sldImg"/>
+          </p:nvPr>
+        </p:nvSpPr>
+        <p:spPr/>
+      </p:sp>
+      <p:sp>
+        <p:nvSpPr>
+          <p:cNvPr id="3" name="Notes Placeholder 2"/>
+          <p:cNvSpPr>
+            <a:spLocks noGrp="1"/>
+          </p:cNvSpPr>
+          <p:nvPr>
+            <p:ph type="body" idx="1"/>
+          </p:nvPr>
+        </p:nvSpPr>
+        <p:spPr/>
+        <p:txBody>
+          <a:bodyPr/>
+          <a:lstStyle/>
+          <a:p>
+            <a:r>
+              <a:rPr lang="en-US" dirty="0"/>
+              <a:t/>
+            </a:r>
+            <a:endParaRPr lang="en-US" dirty="0"/>
+          </a:p>
+        </p:txBody>
+      </p:sp>
+      <p:sp>
+        <p:nvSpPr>
+          <p:cNvPr id="4" name="Slide Number Placeholder 3"/>
+          <p:cNvSpPr>
+            <a:spLocks noGrp="1"/>
+          </p:cNvSpPr>
+          <p:nvPr>
+            <p:ph type="sldNum" sz="quarter" idx="10"/>
+          </p:nvPr>
+        </p:nvSpPr>
+        <p:spPr/>
+        <p:txBody>
+          <a:bodyPr/>
+          <a:lstStyle/>
+          <a:p>
+            <a:fld id="{F7021451-1387-4CA6-816F-3879F97B5CBC}" type="slidenum">
+              <a:rPr lang="en-US"/>
+              <a:t>15</a:t>
             </a:fld>
             <a:endParaRPr lang="en-US"/>
           </a:p>
@@ -3831,6 +3920,45 @@
           </a:graphicData>
         </a:graphic>
       </p:graphicFrame>
+      <p:sp>
+        <p:nvSpPr>
+          <p:cNvPr id="15" name="Text 12"/>
+          <p:cNvSpPr/>
+          <p:nvPr/>
+        </p:nvSpPr>
+        <p:spPr>
+          <a:xfrm>
+            <a:off x="7772400" y="4800600"/>
+            <a:ext cx="1097280" cy="274320"/>
+          </a:xfrm>
+          <a:prstGeom prst="rect">
+            <a:avLst/>
+          </a:prstGeom>
+          <a:noFill/>
+          <a:ln/>
+        </p:spPr>
+        <p:txBody>
+          <a:bodyPr wrap="square" lIns="0" tIns="0" rIns="0" bIns="0" rtlCol="0" anchor="ctr"/>
+          <a:lstStyle/>
+          <a:p>
+            <a:pPr algn="r" indent="0" marL="0">
+              <a:buNone/>
+            </a:pPr>
+            <a:r>
+              <a:rPr lang="en-US" sz="800" dirty="0">
+                <a:solidFill>
+                  <a:srgbClr val="95A5A6"/>
+                </a:solidFill>
+                <a:latin typeface="Calibri" pitchFamily="34" charset="0"/>
+                <a:ea typeface="Calibri" pitchFamily="34" charset="-122"/>
+                <a:cs typeface="Calibri" pitchFamily="34" charset="-120"/>
+              </a:rPr>
+              <a:t>10 / 15</a:t>
+            </a:r>
+            <a:endParaRPr lang="en-US" sz="800" dirty="0"/>
+          </a:p>
+        </p:txBody>
+      </p:sp>
     </p:spTree>
   </p:cSld>
   <p:clrMapOvr>
@@ -4234,6 +4362,45 @@
           </a:p>
         </p:txBody>
       </p:sp>
+      <p:sp>
+        <p:nvSpPr>
+          <p:cNvPr id="13" name="Text 10"/>
+          <p:cNvSpPr/>
+          <p:nvPr/>
+        </p:nvSpPr>
+        <p:spPr>
+          <a:xfrm>
+            <a:off x="7772400" y="4800600"/>
+            <a:ext cx="1097280" cy="274320"/>
+          </a:xfrm>
+          <a:prstGeom prst="rect">
+            <a:avLst/>
+          </a:prstGeom>
+          <a:noFill/>
+          <a:ln/>
+        </p:spPr>
+        <p:txBody>
+          <a:bodyPr wrap="square" lIns="0" tIns="0" rIns="0" bIns="0" rtlCol="0" anchor="ctr"/>
+          <a:lstStyle/>
+          <a:p>
+            <a:pPr algn="r" indent="0" marL="0">
+              <a:buNone/>
+            </a:pPr>
+            <a:r>
+              <a:rPr lang="en-US" sz="800" dirty="0">
+                <a:solidFill>
+                  <a:srgbClr val="95A5A6"/>
+                </a:solidFill>
+                <a:latin typeface="Calibri" pitchFamily="34" charset="0"/>
+                <a:ea typeface="Calibri" pitchFamily="34" charset="-122"/>
+                <a:cs typeface="Calibri" pitchFamily="34" charset="-120"/>
+              </a:rPr>
+              <a:t>11 / 15</a:t>
+            </a:r>
+            <a:endParaRPr lang="en-US" sz="800" dirty="0"/>
+          </a:p>
+        </p:txBody>
+      </p:sp>
     </p:spTree>
   </p:cSld>
   <p:clrMapOvr>
@@ -5037,6 +5204,45 @@
           </a:p>
         </p:txBody>
       </p:sp>
+      <p:sp>
+        <p:nvSpPr>
+          <p:cNvPr id="27" name="Text 19"/>
+          <p:cNvSpPr/>
+          <p:nvPr/>
+        </p:nvSpPr>
+        <p:spPr>
+          <a:xfrm>
+            <a:off x="7772400" y="4800600"/>
+            <a:ext cx="1097280" cy="274320"/>
+          </a:xfrm>
+          <a:prstGeom prst="rect">
+            <a:avLst/>
+          </a:prstGeom>
+          <a:noFill/>
+          <a:ln/>
+        </p:spPr>
+        <p:txBody>
+          <a:bodyPr wrap="square" lIns="0" tIns="0" rIns="0" bIns="0" rtlCol="0" anchor="ctr"/>
+          <a:lstStyle/>
+          <a:p>
+            <a:pPr algn="r" indent="0" marL="0">
+              <a:buNone/>
+            </a:pPr>
+            <a:r>
+              <a:rPr lang="en-US" sz="800" dirty="0">
+                <a:solidFill>
+                  <a:srgbClr val="95A5A6"/>
+                </a:solidFill>
+                <a:latin typeface="Calibri" pitchFamily="34" charset="0"/>
+                <a:ea typeface="Calibri" pitchFamily="34" charset="-122"/>
+                <a:cs typeface="Calibri" pitchFamily="34" charset="-120"/>
+              </a:rPr>
+              <a:t>12 / 15</a:t>
+            </a:r>
+            <a:endParaRPr lang="en-US" sz="800" dirty="0"/>
+          </a:p>
+        </p:txBody>
+      </p:sp>
     </p:spTree>
   </p:cSld>
   <p:clrMapOvr>
@@ -5084,7 +5290,7 @@
             <a:avLst/>
           </a:prstGeom>
           <a:solidFill>
-            <a:srgbClr val="27AE60"/>
+            <a:srgbClr val="1B2838"/>
           </a:solidFill>
           <a:ln/>
         </p:spPr>
@@ -5122,7 +5328,7 @@
                 <a:ea typeface="Arial Black" pitchFamily="34" charset="-122"/>
                 <a:cs typeface="Arial Black" pitchFamily="34" charset="-120"/>
               </a:rPr>
-              <a:t>Hackathon Deliverables</a:t>
+              <a:t>Web-First Integration Strategy</a:t>
             </a:r>
             <a:endParaRPr lang="en-US" sz="2800" dirty="0"/>
           </a:p>
@@ -5130,14 +5336,61 @@
       </p:sp>
       <p:sp>
         <p:nvSpPr>
-          <p:cNvPr id="4" name="Text 2"/>
-          <p:cNvSpPr/>
-          <p:nvPr/>
-        </p:nvSpPr>
-        <p:spPr>
-          <a:xfrm>
-            <a:off x="731520" y="1097280"/>
-            <a:ext cx="7680960" cy="3840480"/>
+          <p:cNvPr id="4" name="Shape 2"/>
+          <p:cNvSpPr/>
+          <p:nvPr/>
+        </p:nvSpPr>
+        <p:spPr>
+          <a:xfrm>
+            <a:off x="457200" y="1143000"/>
+            <a:ext cx="8229600" cy="914400"/>
+          </a:xfrm>
+          <a:prstGeom prst="rect">
+            <a:avLst/>
+          </a:prstGeom>
+          <a:solidFill>
+            <a:srgbClr val="FFFFFF"/>
+          </a:solidFill>
+          <a:ln/>
+          <a:effectLst>
+            <a:outerShdw sx="100000" sy="100000" kx="0" ky="0" algn="bl" rotWithShape="0" blurRad="76200" dist="25400" dir="8100000">
+              <a:srgbClr val="000000">
+                <a:alpha val="15000"/>
+              </a:srgbClr>
+            </a:outerShdw>
+          </a:effectLst>
+        </p:spPr>
+      </p:sp>
+      <p:sp>
+        <p:nvSpPr>
+          <p:cNvPr id="5" name="Shape 3"/>
+          <p:cNvSpPr/>
+          <p:nvPr/>
+        </p:nvSpPr>
+        <p:spPr>
+          <a:xfrm>
+            <a:off x="457200" y="1143000"/>
+            <a:ext cx="73152" cy="914400"/>
+          </a:xfrm>
+          <a:prstGeom prst="rect">
+            <a:avLst/>
+          </a:prstGeom>
+          <a:solidFill>
+            <a:srgbClr val="27AE60"/>
+          </a:solidFill>
+          <a:ln/>
+        </p:spPr>
+      </p:sp>
+      <p:sp>
+        <p:nvSpPr>
+          <p:cNvPr id="6" name="Text 4"/>
+          <p:cNvSpPr/>
+          <p:nvPr/>
+        </p:nvSpPr>
+        <p:spPr>
+          <a:xfrm>
+            <a:off x="777240" y="1188720"/>
+            <a:ext cx="7680960" cy="822960"/>
           </a:xfrm>
           <a:prstGeom prst="rect">
             <a:avLst/>
@@ -5149,256 +5402,1257 @@
           <a:bodyPr wrap="square" lIns="0" tIns="0" rIns="0" bIns="0" rtlCol="0" anchor="ctr"/>
           <a:lstStyle/>
           <a:p>
-            <a:pPr marL="342900" indent="-342900">
-              <a:spcAft>
-                <a:spcPts val="300"/>
-              </a:spcAft>
-              <a:buSzPct val="100000"/>
-              <a:buChar char="•"/>
+            <a:pPr indent="0" marL="0">
+              <a:buNone/>
+            </a:pPr>
+            <a:r>
+              <a:rPr lang="en-US" sz="1400" dirty="0">
+                <a:solidFill>
+                  <a:srgbClr val="2C3E50"/>
+                </a:solidFill>
+                <a:latin typeface="Calibri" pitchFamily="34" charset="0"/>
+                <a:ea typeface="Calibri" pitchFamily="34" charset="-122"/>
+                <a:cs typeface="Calibri" pitchFamily="34" charset="-120"/>
+              </a:rPr>
+              <a:t>AutoCAD Plugin = Thin Client calling the same REST API. Zero duplicated logic. The pipeline is the innovation — not the client.</a:t>
+            </a:r>
+            <a:endParaRPr lang="en-US" sz="1400" dirty="0"/>
+          </a:p>
+        </p:txBody>
+      </p:sp>
+      <p:graphicFrame>
+        <p:nvGraphicFramePr>
+          <p:cNvPr id="14" name="Table 0"/>
+          <p:cNvGraphicFramePr>
+            <a:graphicFrameLocks noGrp="1"/>
+          </p:cNvGraphicFramePr>
+          <p:nvPr>
+            <p:extLst>
+              <p:ext uri="{D42A27DB-BD31-4B8C-83A1-F6EECF244321}">
+                <p14:modId xmlns:p14="http://schemas.microsoft.com/office/powerpoint/2010/main" val="1579011935"/>
+              </p:ext>
+            </p:extLst>
+          </p:nvPr>
+        </p:nvGraphicFramePr>
+        <p:xfrm>
+          <a:off x="457200" y="2331720"/>
+          <a:ext cx="8229600" cy="914400"/>
+        </p:xfrm>
+        <a:graphic>
+          <a:graphicData uri="http://schemas.openxmlformats.org/drawingml/2006/table">
+            <a:tbl>
+              <a:tblPr/>
+              <a:tblGrid>
+                <a:gridCol w="2560320"/>
+                <a:gridCol w="1371600"/>
+                <a:gridCol w="2011680"/>
+                <a:gridCol w="2286000"/>
+              </a:tblGrid>
+              <a:tr h="365760">
+                <a:tc>
+                  <a:txBody>
+                    <a:bodyPr/>
+                    <a:lstStyle/>
+                    <a:p>
+                      <a:pPr indent="0" marL="0">
+                        <a:buNone/>
+                      </a:pPr>
+                      <a:r>
+                        <a:rPr lang="en-US" sz="1200" b="1" dirty="0">
+                          <a:solidFill>
+                            <a:srgbClr val="FFFFFF"/>
+                          </a:solidFill>
+                          <a:latin typeface="Calibri" pitchFamily="34" charset="0"/>
+                          <a:ea typeface="Calibri" pitchFamily="34" charset="-122"/>
+                          <a:cs typeface="Calibri" pitchFamily="34" charset="-120"/>
+                        </a:rPr>
+                        <a:t>Approach</a:t>
+                      </a:r>
+                      <a:endParaRPr lang="en-US" sz="1200" dirty="0">
+                        <a:latin typeface="Calibri" charset="0"/>
+                        <a:ea typeface="Calibri" charset="0"/>
+                        <a:cs typeface="Calibri" charset="0"/>
+                      </a:endParaRPr>
+                    </a:p>
+                  </a:txBody>
+                  <a:tcPr marL="91440" marR="91440" marT="45720" marB="45720">
+                    <a:lnL w="6350" cap="flat" cmpd="sng" algn="ctr">
+                      <a:solidFill>
+                        <a:srgbClr val="ECF0F1"/>
+                      </a:solidFill>
+                      <a:prstDash val="solid"/>
+                      <a:round/>
+                      <a:headEnd type="none" w="med" len="med"/>
+                      <a:tailEnd type="none" w="med" len="med"/>
+                    </a:lnL>
+                    <a:lnR w="6350" cap="flat" cmpd="sng" algn="ctr">
+                      <a:solidFill>
+                        <a:srgbClr val="ECF0F1"/>
+                      </a:solidFill>
+                      <a:prstDash val="solid"/>
+                      <a:round/>
+                      <a:headEnd type="none" w="med" len="med"/>
+                      <a:tailEnd type="none" w="med" len="med"/>
+                    </a:lnR>
+                    <a:lnT w="6350" cap="flat" cmpd="sng" algn="ctr">
+                      <a:solidFill>
+                        <a:srgbClr val="ECF0F1"/>
+                      </a:solidFill>
+                      <a:prstDash val="solid"/>
+                      <a:round/>
+                      <a:headEnd type="none" w="med" len="med"/>
+                      <a:tailEnd type="none" w="med" len="med"/>
+                    </a:lnT>
+                    <a:lnB w="6350" cap="flat" cmpd="sng" algn="ctr">
+                      <a:solidFill>
+                        <a:srgbClr val="ECF0F1"/>
+                      </a:solidFill>
+                      <a:prstDash val="solid"/>
+                      <a:round/>
+                      <a:headEnd type="none" w="med" len="med"/>
+                      <a:tailEnd type="none" w="med" len="med"/>
+                    </a:lnB>
+                    <a:solidFill>
+                      <a:srgbClr val="2C3E50"/>
+                    </a:solidFill>
+                  </a:tcPr>
+                </a:tc>
+                <a:tc>
+                  <a:txBody>
+                    <a:bodyPr/>
+                    <a:lstStyle/>
+                    <a:p>
+                      <a:pPr indent="0" marL="0">
+                        <a:buNone/>
+                      </a:pPr>
+                      <a:r>
+                        <a:rPr lang="en-US" sz="1200" b="1" dirty="0">
+                          <a:solidFill>
+                            <a:srgbClr val="FFFFFF"/>
+                          </a:solidFill>
+                          <a:latin typeface="Calibri" pitchFamily="34" charset="0"/>
+                          <a:ea typeface="Calibri" pitchFamily="34" charset="-122"/>
+                          <a:cs typeface="Calibri" pitchFamily="34" charset="-120"/>
+                        </a:rPr>
+                        <a:t>Effort</a:t>
+                      </a:r>
+                      <a:endParaRPr lang="en-US" sz="1200" dirty="0">
+                        <a:latin typeface="Calibri" charset="0"/>
+                        <a:ea typeface="Calibri" charset="0"/>
+                        <a:cs typeface="Calibri" charset="0"/>
+                      </a:endParaRPr>
+                    </a:p>
+                  </a:txBody>
+                  <a:tcPr marL="91440" marR="91440" marT="45720" marB="45720">
+                    <a:lnL w="6350" cap="flat" cmpd="sng" algn="ctr">
+                      <a:solidFill>
+                        <a:srgbClr val="ECF0F1"/>
+                      </a:solidFill>
+                      <a:prstDash val="solid"/>
+                      <a:round/>
+                      <a:headEnd type="none" w="med" len="med"/>
+                      <a:tailEnd type="none" w="med" len="med"/>
+                    </a:lnL>
+                    <a:lnR w="6350" cap="flat" cmpd="sng" algn="ctr">
+                      <a:solidFill>
+                        <a:srgbClr val="ECF0F1"/>
+                      </a:solidFill>
+                      <a:prstDash val="solid"/>
+                      <a:round/>
+                      <a:headEnd type="none" w="med" len="med"/>
+                      <a:tailEnd type="none" w="med" len="med"/>
+                    </a:lnR>
+                    <a:lnT w="6350" cap="flat" cmpd="sng" algn="ctr">
+                      <a:solidFill>
+                        <a:srgbClr val="ECF0F1"/>
+                      </a:solidFill>
+                      <a:prstDash val="solid"/>
+                      <a:round/>
+                      <a:headEnd type="none" w="med" len="med"/>
+                      <a:tailEnd type="none" w="med" len="med"/>
+                    </a:lnT>
+                    <a:lnB w="6350" cap="flat" cmpd="sng" algn="ctr">
+                      <a:solidFill>
+                        <a:srgbClr val="ECF0F1"/>
+                      </a:solidFill>
+                      <a:prstDash val="solid"/>
+                      <a:round/>
+                      <a:headEnd type="none" w="med" len="med"/>
+                      <a:tailEnd type="none" w="med" len="med"/>
+                    </a:lnB>
+                    <a:solidFill>
+                      <a:srgbClr val="2C3E50"/>
+                    </a:solidFill>
+                  </a:tcPr>
+                </a:tc>
+                <a:tc>
+                  <a:txBody>
+                    <a:bodyPr/>
+                    <a:lstStyle/>
+                    <a:p>
+                      <a:pPr indent="0" marL="0">
+                        <a:buNone/>
+                      </a:pPr>
+                      <a:r>
+                        <a:rPr lang="en-US" sz="1200" b="1" dirty="0">
+                          <a:solidFill>
+                            <a:srgbClr val="FFFFFF"/>
+                          </a:solidFill>
+                          <a:latin typeface="Calibri" pitchFamily="34" charset="0"/>
+                          <a:ea typeface="Calibri" pitchFamily="34" charset="-122"/>
+                          <a:cs typeface="Calibri" pitchFamily="34" charset="-120"/>
+                        </a:rPr>
+                        <a:t>Maintenance</a:t>
+                      </a:r>
+                      <a:endParaRPr lang="en-US" sz="1200" dirty="0">
+                        <a:latin typeface="Calibri" charset="0"/>
+                        <a:ea typeface="Calibri" charset="0"/>
+                        <a:cs typeface="Calibri" charset="0"/>
+                      </a:endParaRPr>
+                    </a:p>
+                  </a:txBody>
+                  <a:tcPr marL="91440" marR="91440" marT="45720" marB="45720">
+                    <a:lnL w="6350" cap="flat" cmpd="sng" algn="ctr">
+                      <a:solidFill>
+                        <a:srgbClr val="ECF0F1"/>
+                      </a:solidFill>
+                      <a:prstDash val="solid"/>
+                      <a:round/>
+                      <a:headEnd type="none" w="med" len="med"/>
+                      <a:tailEnd type="none" w="med" len="med"/>
+                    </a:lnL>
+                    <a:lnR w="6350" cap="flat" cmpd="sng" algn="ctr">
+                      <a:solidFill>
+                        <a:srgbClr val="ECF0F1"/>
+                      </a:solidFill>
+                      <a:prstDash val="solid"/>
+                      <a:round/>
+                      <a:headEnd type="none" w="med" len="med"/>
+                      <a:tailEnd type="none" w="med" len="med"/>
+                    </a:lnR>
+                    <a:lnT w="6350" cap="flat" cmpd="sng" algn="ctr">
+                      <a:solidFill>
+                        <a:srgbClr val="ECF0F1"/>
+                      </a:solidFill>
+                      <a:prstDash val="solid"/>
+                      <a:round/>
+                      <a:headEnd type="none" w="med" len="med"/>
+                      <a:tailEnd type="none" w="med" len="med"/>
+                    </a:lnT>
+                    <a:lnB w="6350" cap="flat" cmpd="sng" algn="ctr">
+                      <a:solidFill>
+                        <a:srgbClr val="ECF0F1"/>
+                      </a:solidFill>
+                      <a:prstDash val="solid"/>
+                      <a:round/>
+                      <a:headEnd type="none" w="med" len="med"/>
+                      <a:tailEnd type="none" w="med" len="med"/>
+                    </a:lnB>
+                    <a:solidFill>
+                      <a:srgbClr val="2C3E50"/>
+                    </a:solidFill>
+                  </a:tcPr>
+                </a:tc>
+                <a:tc>
+                  <a:txBody>
+                    <a:bodyPr/>
+                    <a:lstStyle/>
+                    <a:p>
+                      <a:pPr indent="0" marL="0">
+                        <a:buNone/>
+                      </a:pPr>
+                      <a:r>
+                        <a:rPr lang="en-US" sz="1200" b="1" dirty="0">
+                          <a:solidFill>
+                            <a:srgbClr val="FFFFFF"/>
+                          </a:solidFill>
+                          <a:latin typeface="Calibri" pitchFamily="34" charset="0"/>
+                          <a:ea typeface="Calibri" pitchFamily="34" charset="-122"/>
+                          <a:cs typeface="Calibri" pitchFamily="34" charset="-120"/>
+                        </a:rPr>
+                        <a:t>Reach</a:t>
+                      </a:r>
+                      <a:endParaRPr lang="en-US" sz="1200" dirty="0">
+                        <a:latin typeface="Calibri" charset="0"/>
+                        <a:ea typeface="Calibri" charset="0"/>
+                        <a:cs typeface="Calibri" charset="0"/>
+                      </a:endParaRPr>
+                    </a:p>
+                  </a:txBody>
+                  <a:tcPr marL="91440" marR="91440" marT="45720" marB="45720">
+                    <a:lnL w="6350" cap="flat" cmpd="sng" algn="ctr">
+                      <a:solidFill>
+                        <a:srgbClr val="ECF0F1"/>
+                      </a:solidFill>
+                      <a:prstDash val="solid"/>
+                      <a:round/>
+                      <a:headEnd type="none" w="med" len="med"/>
+                      <a:tailEnd type="none" w="med" len="med"/>
+                    </a:lnL>
+                    <a:lnR w="6350" cap="flat" cmpd="sng" algn="ctr">
+                      <a:solidFill>
+                        <a:srgbClr val="ECF0F1"/>
+                      </a:solidFill>
+                      <a:prstDash val="solid"/>
+                      <a:round/>
+                      <a:headEnd type="none" w="med" len="med"/>
+                      <a:tailEnd type="none" w="med" len="med"/>
+                    </a:lnR>
+                    <a:lnT w="6350" cap="flat" cmpd="sng" algn="ctr">
+                      <a:solidFill>
+                        <a:srgbClr val="ECF0F1"/>
+                      </a:solidFill>
+                      <a:prstDash val="solid"/>
+                      <a:round/>
+                      <a:headEnd type="none" w="med" len="med"/>
+                      <a:tailEnd type="none" w="med" len="med"/>
+                    </a:lnT>
+                    <a:lnB w="6350" cap="flat" cmpd="sng" algn="ctr">
+                      <a:solidFill>
+                        <a:srgbClr val="ECF0F1"/>
+                      </a:solidFill>
+                      <a:prstDash val="solid"/>
+                      <a:round/>
+                      <a:headEnd type="none" w="med" len="med"/>
+                      <a:tailEnd type="none" w="med" len="med"/>
+                    </a:lnB>
+                    <a:solidFill>
+                      <a:srgbClr val="2C3E50"/>
+                    </a:solidFill>
+                  </a:tcPr>
+                </a:tc>
+              </a:tr>
+              <a:tr h="365760">
+                <a:tc>
+                  <a:txBody>
+                    <a:bodyPr/>
+                    <a:lstStyle/>
+                    <a:p>
+                      <a:pPr indent="0" marL="0">
+                        <a:buNone/>
+                      </a:pPr>
+                      <a:r>
+                        <a:rPr lang="en-US" sz="1100" b="1" dirty="0">
+                          <a:solidFill>
+                            <a:srgbClr val="27AE60"/>
+                          </a:solidFill>
+                          <a:latin typeface="Calibri" pitchFamily="34" charset="0"/>
+                          <a:ea typeface="Calibri" pitchFamily="34" charset="-122"/>
+                          <a:cs typeface="Calibri" pitchFamily="34" charset="-120"/>
+                        </a:rPr>
+                        <a:t>Web App (current)</a:t>
+                      </a:r>
+                      <a:endParaRPr lang="en-US" sz="1100" dirty="0">
+                        <a:latin typeface="Calibri" charset="0"/>
+                        <a:ea typeface="Calibri" charset="0"/>
+                        <a:cs typeface="Calibri" charset="0"/>
+                      </a:endParaRPr>
+                    </a:p>
+                  </a:txBody>
+                  <a:tcPr marL="91440" marR="91440" marT="45720" marB="45720">
+                    <a:lnL w="6350" cap="flat" cmpd="sng" algn="ctr">
+                      <a:solidFill>
+                        <a:srgbClr val="ECF0F1"/>
+                      </a:solidFill>
+                      <a:prstDash val="solid"/>
+                      <a:round/>
+                      <a:headEnd type="none" w="med" len="med"/>
+                      <a:tailEnd type="none" w="med" len="med"/>
+                    </a:lnL>
+                    <a:lnR w="6350" cap="flat" cmpd="sng" algn="ctr">
+                      <a:solidFill>
+                        <a:srgbClr val="ECF0F1"/>
+                      </a:solidFill>
+                      <a:prstDash val="solid"/>
+                      <a:round/>
+                      <a:headEnd type="none" w="med" len="med"/>
+                      <a:tailEnd type="none" w="med" len="med"/>
+                    </a:lnR>
+                    <a:lnT w="6350" cap="flat" cmpd="sng" algn="ctr">
+                      <a:solidFill>
+                        <a:srgbClr val="ECF0F1"/>
+                      </a:solidFill>
+                      <a:prstDash val="solid"/>
+                      <a:round/>
+                      <a:headEnd type="none" w="med" len="med"/>
+                      <a:tailEnd type="none" w="med" len="med"/>
+                    </a:lnT>
+                    <a:lnB w="6350" cap="flat" cmpd="sng" algn="ctr">
+                      <a:solidFill>
+                        <a:srgbClr val="ECF0F1"/>
+                      </a:solidFill>
+                      <a:prstDash val="solid"/>
+                      <a:round/>
+                      <a:headEnd type="none" w="med" len="med"/>
+                      <a:tailEnd type="none" w="med" len="med"/>
+                    </a:lnB>
+                  </a:tcPr>
+                </a:tc>
+                <a:tc>
+                  <a:txBody>
+                    <a:bodyPr/>
+                    <a:lstStyle/>
+                    <a:p>
+                      <a:pPr indent="0" marL="0">
+                        <a:buNone/>
+                      </a:pPr>
+                      <a:r>
+                        <a:rPr lang="en-US" sz="1100" dirty="0">
+                          <a:solidFill>
+                            <a:srgbClr val="2C3E50"/>
+                          </a:solidFill>
+                          <a:latin typeface="Calibri" pitchFamily="34" charset="0"/>
+                          <a:ea typeface="Calibri" pitchFamily="34" charset="-122"/>
+                          <a:cs typeface="Calibri" pitchFamily="34" charset="-120"/>
+                        </a:rPr>
+                        <a:t>Low</a:t>
+                      </a:r>
+                      <a:endParaRPr lang="en-US" sz="1100" dirty="0">
+                        <a:latin typeface="Calibri" charset="0"/>
+                        <a:ea typeface="Calibri" charset="0"/>
+                        <a:cs typeface="Calibri" charset="0"/>
+                      </a:endParaRPr>
+                    </a:p>
+                  </a:txBody>
+                  <a:tcPr marL="91440" marR="91440" marT="45720" marB="45720">
+                    <a:lnL w="6350" cap="flat" cmpd="sng" algn="ctr">
+                      <a:solidFill>
+                        <a:srgbClr val="ECF0F1"/>
+                      </a:solidFill>
+                      <a:prstDash val="solid"/>
+                      <a:round/>
+                      <a:headEnd type="none" w="med" len="med"/>
+                      <a:tailEnd type="none" w="med" len="med"/>
+                    </a:lnL>
+                    <a:lnR w="6350" cap="flat" cmpd="sng" algn="ctr">
+                      <a:solidFill>
+                        <a:srgbClr val="ECF0F1"/>
+                      </a:solidFill>
+                      <a:prstDash val="solid"/>
+                      <a:round/>
+                      <a:headEnd type="none" w="med" len="med"/>
+                      <a:tailEnd type="none" w="med" len="med"/>
+                    </a:lnR>
+                    <a:lnT w="6350" cap="flat" cmpd="sng" algn="ctr">
+                      <a:solidFill>
+                        <a:srgbClr val="ECF0F1"/>
+                      </a:solidFill>
+                      <a:prstDash val="solid"/>
+                      <a:round/>
+                      <a:headEnd type="none" w="med" len="med"/>
+                      <a:tailEnd type="none" w="med" len="med"/>
+                    </a:lnT>
+                    <a:lnB w="6350" cap="flat" cmpd="sng" algn="ctr">
+                      <a:solidFill>
+                        <a:srgbClr val="ECF0F1"/>
+                      </a:solidFill>
+                      <a:prstDash val="solid"/>
+                      <a:round/>
+                      <a:headEnd type="none" w="med" len="med"/>
+                      <a:tailEnd type="none" w="med" len="med"/>
+                    </a:lnB>
+                  </a:tcPr>
+                </a:tc>
+                <a:tc>
+                  <a:txBody>
+                    <a:bodyPr/>
+                    <a:lstStyle/>
+                    <a:p>
+                      <a:pPr indent="0" marL="0">
+                        <a:buNone/>
+                      </a:pPr>
+                      <a:r>
+                        <a:rPr lang="en-US" sz="1100" dirty="0">
+                          <a:solidFill>
+                            <a:srgbClr val="2C3E50"/>
+                          </a:solidFill>
+                          <a:latin typeface="Calibri" pitchFamily="34" charset="0"/>
+                          <a:ea typeface="Calibri" pitchFamily="34" charset="-122"/>
+                          <a:cs typeface="Calibri" pitchFamily="34" charset="-120"/>
+                        </a:rPr>
+                        <a:t>Low</a:t>
+                      </a:r>
+                      <a:endParaRPr lang="en-US" sz="1100" dirty="0">
+                        <a:latin typeface="Calibri" charset="0"/>
+                        <a:ea typeface="Calibri" charset="0"/>
+                        <a:cs typeface="Calibri" charset="0"/>
+                      </a:endParaRPr>
+                    </a:p>
+                  </a:txBody>
+                  <a:tcPr marL="91440" marR="91440" marT="45720" marB="45720">
+                    <a:lnL w="6350" cap="flat" cmpd="sng" algn="ctr">
+                      <a:solidFill>
+                        <a:srgbClr val="ECF0F1"/>
+                      </a:solidFill>
+                      <a:prstDash val="solid"/>
+                      <a:round/>
+                      <a:headEnd type="none" w="med" len="med"/>
+                      <a:tailEnd type="none" w="med" len="med"/>
+                    </a:lnL>
+                    <a:lnR w="6350" cap="flat" cmpd="sng" algn="ctr">
+                      <a:solidFill>
+                        <a:srgbClr val="ECF0F1"/>
+                      </a:solidFill>
+                      <a:prstDash val="solid"/>
+                      <a:round/>
+                      <a:headEnd type="none" w="med" len="med"/>
+                      <a:tailEnd type="none" w="med" len="med"/>
+                    </a:lnR>
+                    <a:lnT w="6350" cap="flat" cmpd="sng" algn="ctr">
+                      <a:solidFill>
+                        <a:srgbClr val="ECF0F1"/>
+                      </a:solidFill>
+                      <a:prstDash val="solid"/>
+                      <a:round/>
+                      <a:headEnd type="none" w="med" len="med"/>
+                      <a:tailEnd type="none" w="med" len="med"/>
+                    </a:lnT>
+                    <a:lnB w="6350" cap="flat" cmpd="sng" algn="ctr">
+                      <a:solidFill>
+                        <a:srgbClr val="ECF0F1"/>
+                      </a:solidFill>
+                      <a:prstDash val="solid"/>
+                      <a:round/>
+                      <a:headEnd type="none" w="med" len="med"/>
+                      <a:tailEnd type="none" w="med" len="med"/>
+                    </a:lnB>
+                  </a:tcPr>
+                </a:tc>
+                <a:tc>
+                  <a:txBody>
+                    <a:bodyPr/>
+                    <a:lstStyle/>
+                    <a:p>
+                      <a:pPr indent="0" marL="0">
+                        <a:buNone/>
+                      </a:pPr>
+                      <a:r>
+                        <a:rPr lang="en-US" sz="1100" dirty="0">
+                          <a:solidFill>
+                            <a:srgbClr val="2C3E50"/>
+                          </a:solidFill>
+                          <a:latin typeface="Calibri" pitchFamily="34" charset="0"/>
+                          <a:ea typeface="Calibri" pitchFamily="34" charset="-122"/>
+                          <a:cs typeface="Calibri" pitchFamily="34" charset="-120"/>
+                        </a:rPr>
+                        <a:t>Any browser, any device</a:t>
+                      </a:r>
+                      <a:endParaRPr lang="en-US" sz="1100" dirty="0">
+                        <a:latin typeface="Calibri" charset="0"/>
+                        <a:ea typeface="Calibri" charset="0"/>
+                        <a:cs typeface="Calibri" charset="0"/>
+                      </a:endParaRPr>
+                    </a:p>
+                  </a:txBody>
+                  <a:tcPr marL="91440" marR="91440" marT="45720" marB="45720">
+                    <a:lnL w="6350" cap="flat" cmpd="sng" algn="ctr">
+                      <a:solidFill>
+                        <a:srgbClr val="ECF0F1"/>
+                      </a:solidFill>
+                      <a:prstDash val="solid"/>
+                      <a:round/>
+                      <a:headEnd type="none" w="med" len="med"/>
+                      <a:tailEnd type="none" w="med" len="med"/>
+                    </a:lnL>
+                    <a:lnR w="6350" cap="flat" cmpd="sng" algn="ctr">
+                      <a:solidFill>
+                        <a:srgbClr val="ECF0F1"/>
+                      </a:solidFill>
+                      <a:prstDash val="solid"/>
+                      <a:round/>
+                      <a:headEnd type="none" w="med" len="med"/>
+                      <a:tailEnd type="none" w="med" len="med"/>
+                    </a:lnR>
+                    <a:lnT w="6350" cap="flat" cmpd="sng" algn="ctr">
+                      <a:solidFill>
+                        <a:srgbClr val="ECF0F1"/>
+                      </a:solidFill>
+                      <a:prstDash val="solid"/>
+                      <a:round/>
+                      <a:headEnd type="none" w="med" len="med"/>
+                      <a:tailEnd type="none" w="med" len="med"/>
+                    </a:lnT>
+                    <a:lnB w="6350" cap="flat" cmpd="sng" algn="ctr">
+                      <a:solidFill>
+                        <a:srgbClr val="ECF0F1"/>
+                      </a:solidFill>
+                      <a:prstDash val="solid"/>
+                      <a:round/>
+                      <a:headEnd type="none" w="med" len="med"/>
+                      <a:tailEnd type="none" w="med" len="med"/>
+                    </a:lnB>
+                  </a:tcPr>
+                </a:tc>
+              </a:tr>
+              <a:tr h="365760">
+                <a:tc>
+                  <a:txBody>
+                    <a:bodyPr/>
+                    <a:lstStyle/>
+                    <a:p>
+                      <a:pPr indent="0" marL="0">
+                        <a:buNone/>
+                      </a:pPr>
+                      <a:r>
+                        <a:rPr lang="en-US" sz="1100" dirty="0">
+                          <a:solidFill>
+                            <a:srgbClr val="2C3E50"/>
+                          </a:solidFill>
+                          <a:latin typeface="Calibri" pitchFamily="34" charset="0"/>
+                          <a:ea typeface="Calibri" pitchFamily="34" charset="-122"/>
+                          <a:cs typeface="Calibri" pitchFamily="34" charset="-120"/>
+                        </a:rPr>
+                        <a:t>AutoCAD Plugin (.NET)</a:t>
+                      </a:r>
+                      <a:endParaRPr lang="en-US" sz="1100" dirty="0">
+                        <a:latin typeface="Calibri" charset="0"/>
+                        <a:ea typeface="Calibri" charset="0"/>
+                        <a:cs typeface="Calibri" charset="0"/>
+                      </a:endParaRPr>
+                    </a:p>
+                  </a:txBody>
+                  <a:tcPr marL="91440" marR="91440" marT="45720" marB="45720">
+                    <a:lnL w="6350" cap="flat" cmpd="sng" algn="ctr">
+                      <a:solidFill>
+                        <a:srgbClr val="ECF0F1"/>
+                      </a:solidFill>
+                      <a:prstDash val="solid"/>
+                      <a:round/>
+                      <a:headEnd type="none" w="med" len="med"/>
+                      <a:tailEnd type="none" w="med" len="med"/>
+                    </a:lnL>
+                    <a:lnR w="6350" cap="flat" cmpd="sng" algn="ctr">
+                      <a:solidFill>
+                        <a:srgbClr val="ECF0F1"/>
+                      </a:solidFill>
+                      <a:prstDash val="solid"/>
+                      <a:round/>
+                      <a:headEnd type="none" w="med" len="med"/>
+                      <a:tailEnd type="none" w="med" len="med"/>
+                    </a:lnR>
+                    <a:lnT w="6350" cap="flat" cmpd="sng" algn="ctr">
+                      <a:solidFill>
+                        <a:srgbClr val="ECF0F1"/>
+                      </a:solidFill>
+                      <a:prstDash val="solid"/>
+                      <a:round/>
+                      <a:headEnd type="none" w="med" len="med"/>
+                      <a:tailEnd type="none" w="med" len="med"/>
+                    </a:lnT>
+                    <a:lnB w="6350" cap="flat" cmpd="sng" algn="ctr">
+                      <a:solidFill>
+                        <a:srgbClr val="ECF0F1"/>
+                      </a:solidFill>
+                      <a:prstDash val="solid"/>
+                      <a:round/>
+                      <a:headEnd type="none" w="med" len="med"/>
+                      <a:tailEnd type="none" w="med" len="med"/>
+                    </a:lnB>
+                  </a:tcPr>
+                </a:tc>
+                <a:tc>
+                  <a:txBody>
+                    <a:bodyPr/>
+                    <a:lstStyle/>
+                    <a:p>
+                      <a:pPr indent="0" marL="0">
+                        <a:buNone/>
+                      </a:pPr>
+                      <a:r>
+                        <a:rPr lang="en-US" sz="1100" dirty="0">
+                          <a:solidFill>
+                            <a:srgbClr val="2C3E50"/>
+                          </a:solidFill>
+                          <a:latin typeface="Calibri" pitchFamily="34" charset="0"/>
+                          <a:ea typeface="Calibri" pitchFamily="34" charset="-122"/>
+                          <a:cs typeface="Calibri" pitchFamily="34" charset="-120"/>
+                        </a:rPr>
+                        <a:t>High</a:t>
+                      </a:r>
+                      <a:endParaRPr lang="en-US" sz="1100" dirty="0">
+                        <a:latin typeface="Calibri" charset="0"/>
+                        <a:ea typeface="Calibri" charset="0"/>
+                        <a:cs typeface="Calibri" charset="0"/>
+                      </a:endParaRPr>
+                    </a:p>
+                  </a:txBody>
+                  <a:tcPr marL="91440" marR="91440" marT="45720" marB="45720">
+                    <a:lnL w="6350" cap="flat" cmpd="sng" algn="ctr">
+                      <a:solidFill>
+                        <a:srgbClr val="ECF0F1"/>
+                      </a:solidFill>
+                      <a:prstDash val="solid"/>
+                      <a:round/>
+                      <a:headEnd type="none" w="med" len="med"/>
+                      <a:tailEnd type="none" w="med" len="med"/>
+                    </a:lnL>
+                    <a:lnR w="6350" cap="flat" cmpd="sng" algn="ctr">
+                      <a:solidFill>
+                        <a:srgbClr val="ECF0F1"/>
+                      </a:solidFill>
+                      <a:prstDash val="solid"/>
+                      <a:round/>
+                      <a:headEnd type="none" w="med" len="med"/>
+                      <a:tailEnd type="none" w="med" len="med"/>
+                    </a:lnR>
+                    <a:lnT w="6350" cap="flat" cmpd="sng" algn="ctr">
+                      <a:solidFill>
+                        <a:srgbClr val="ECF0F1"/>
+                      </a:solidFill>
+                      <a:prstDash val="solid"/>
+                      <a:round/>
+                      <a:headEnd type="none" w="med" len="med"/>
+                      <a:tailEnd type="none" w="med" len="med"/>
+                    </a:lnT>
+                    <a:lnB w="6350" cap="flat" cmpd="sng" algn="ctr">
+                      <a:solidFill>
+                        <a:srgbClr val="ECF0F1"/>
+                      </a:solidFill>
+                      <a:prstDash val="solid"/>
+                      <a:round/>
+                      <a:headEnd type="none" w="med" len="med"/>
+                      <a:tailEnd type="none" w="med" len="med"/>
+                    </a:lnB>
+                  </a:tcPr>
+                </a:tc>
+                <a:tc>
+                  <a:txBody>
+                    <a:bodyPr/>
+                    <a:lstStyle/>
+                    <a:p>
+                      <a:pPr indent="0" marL="0">
+                        <a:buNone/>
+                      </a:pPr>
+                      <a:r>
+                        <a:rPr lang="en-US" sz="1100" dirty="0">
+                          <a:solidFill>
+                            <a:srgbClr val="2C3E50"/>
+                          </a:solidFill>
+                          <a:latin typeface="Calibri" pitchFamily="34" charset="0"/>
+                          <a:ea typeface="Calibri" pitchFamily="34" charset="-122"/>
+                          <a:cs typeface="Calibri" pitchFamily="34" charset="-120"/>
+                        </a:rPr>
+                        <a:t>High (version-locked)</a:t>
+                      </a:r>
+                      <a:endParaRPr lang="en-US" sz="1100" dirty="0">
+                        <a:latin typeface="Calibri" charset="0"/>
+                        <a:ea typeface="Calibri" charset="0"/>
+                        <a:cs typeface="Calibri" charset="0"/>
+                      </a:endParaRPr>
+                    </a:p>
+                  </a:txBody>
+                  <a:tcPr marL="91440" marR="91440" marT="45720" marB="45720">
+                    <a:lnL w="6350" cap="flat" cmpd="sng" algn="ctr">
+                      <a:solidFill>
+                        <a:srgbClr val="ECF0F1"/>
+                      </a:solidFill>
+                      <a:prstDash val="solid"/>
+                      <a:round/>
+                      <a:headEnd type="none" w="med" len="med"/>
+                      <a:tailEnd type="none" w="med" len="med"/>
+                    </a:lnL>
+                    <a:lnR w="6350" cap="flat" cmpd="sng" algn="ctr">
+                      <a:solidFill>
+                        <a:srgbClr val="ECF0F1"/>
+                      </a:solidFill>
+                      <a:prstDash val="solid"/>
+                      <a:round/>
+                      <a:headEnd type="none" w="med" len="med"/>
+                      <a:tailEnd type="none" w="med" len="med"/>
+                    </a:lnR>
+                    <a:lnT w="6350" cap="flat" cmpd="sng" algn="ctr">
+                      <a:solidFill>
+                        <a:srgbClr val="ECF0F1"/>
+                      </a:solidFill>
+                      <a:prstDash val="solid"/>
+                      <a:round/>
+                      <a:headEnd type="none" w="med" len="med"/>
+                      <a:tailEnd type="none" w="med" len="med"/>
+                    </a:lnT>
+                    <a:lnB w="6350" cap="flat" cmpd="sng" algn="ctr">
+                      <a:solidFill>
+                        <a:srgbClr val="ECF0F1"/>
+                      </a:solidFill>
+                      <a:prstDash val="solid"/>
+                      <a:round/>
+                      <a:headEnd type="none" w="med" len="med"/>
+                      <a:tailEnd type="none" w="med" len="med"/>
+                    </a:lnB>
+                  </a:tcPr>
+                </a:tc>
+                <a:tc>
+                  <a:txBody>
+                    <a:bodyPr/>
+                    <a:lstStyle/>
+                    <a:p>
+                      <a:pPr indent="0" marL="0">
+                        <a:buNone/>
+                      </a:pPr>
+                      <a:r>
+                        <a:rPr lang="en-US" sz="1100" dirty="0">
+                          <a:solidFill>
+                            <a:srgbClr val="2C3E50"/>
+                          </a:solidFill>
+                          <a:latin typeface="Calibri" pitchFamily="34" charset="0"/>
+                          <a:ea typeface="Calibri" pitchFamily="34" charset="-122"/>
+                          <a:cs typeface="Calibri" pitchFamily="34" charset="-120"/>
+                        </a:rPr>
+                        <a:t>AutoCAD Desktop only</a:t>
+                      </a:r>
+                      <a:endParaRPr lang="en-US" sz="1100" dirty="0">
+                        <a:latin typeface="Calibri" charset="0"/>
+                        <a:ea typeface="Calibri" charset="0"/>
+                        <a:cs typeface="Calibri" charset="0"/>
+                      </a:endParaRPr>
+                    </a:p>
+                  </a:txBody>
+                  <a:tcPr marL="91440" marR="91440" marT="45720" marB="45720">
+                    <a:lnL w="6350" cap="flat" cmpd="sng" algn="ctr">
+                      <a:solidFill>
+                        <a:srgbClr val="ECF0F1"/>
+                      </a:solidFill>
+                      <a:prstDash val="solid"/>
+                      <a:round/>
+                      <a:headEnd type="none" w="med" len="med"/>
+                      <a:tailEnd type="none" w="med" len="med"/>
+                    </a:lnL>
+                    <a:lnR w="6350" cap="flat" cmpd="sng" algn="ctr">
+                      <a:solidFill>
+                        <a:srgbClr val="ECF0F1"/>
+                      </a:solidFill>
+                      <a:prstDash val="solid"/>
+                      <a:round/>
+                      <a:headEnd type="none" w="med" len="med"/>
+                      <a:tailEnd type="none" w="med" len="med"/>
+                    </a:lnR>
+                    <a:lnT w="6350" cap="flat" cmpd="sng" algn="ctr">
+                      <a:solidFill>
+                        <a:srgbClr val="ECF0F1"/>
+                      </a:solidFill>
+                      <a:prstDash val="solid"/>
+                      <a:round/>
+                      <a:headEnd type="none" w="med" len="med"/>
+                      <a:tailEnd type="none" w="med" len="med"/>
+                    </a:lnT>
+                    <a:lnB w="6350" cap="flat" cmpd="sng" algn="ctr">
+                      <a:solidFill>
+                        <a:srgbClr val="ECF0F1"/>
+                      </a:solidFill>
+                      <a:prstDash val="solid"/>
+                      <a:round/>
+                      <a:headEnd type="none" w="med" len="med"/>
+                      <a:tailEnd type="none" w="med" len="med"/>
+                    </a:lnB>
+                  </a:tcPr>
+                </a:tc>
+              </a:tr>
+              <a:tr h="365760">
+                <a:tc>
+                  <a:txBody>
+                    <a:bodyPr/>
+                    <a:lstStyle/>
+                    <a:p>
+                      <a:pPr indent="0" marL="0">
+                        <a:buNone/>
+                      </a:pPr>
+                      <a:r>
+                        <a:rPr lang="en-US" sz="1100" dirty="0">
+                          <a:solidFill>
+                            <a:srgbClr val="2C3E50"/>
+                          </a:solidFill>
+                          <a:latin typeface="Calibri" pitchFamily="34" charset="0"/>
+                          <a:ea typeface="Calibri" pitchFamily="34" charset="-122"/>
+                          <a:cs typeface="Calibri" pitchFamily="34" charset="-120"/>
+                        </a:rPr>
+                        <a:t>Revit Add-in</a:t>
+                      </a:r>
+                      <a:endParaRPr lang="en-US" sz="1100" dirty="0">
+                        <a:latin typeface="Calibri" charset="0"/>
+                        <a:ea typeface="Calibri" charset="0"/>
+                        <a:cs typeface="Calibri" charset="0"/>
+                      </a:endParaRPr>
+                    </a:p>
+                  </a:txBody>
+                  <a:tcPr marL="91440" marR="91440" marT="45720" marB="45720">
+                    <a:lnL w="6350" cap="flat" cmpd="sng" algn="ctr">
+                      <a:solidFill>
+                        <a:srgbClr val="ECF0F1"/>
+                      </a:solidFill>
+                      <a:prstDash val="solid"/>
+                      <a:round/>
+                      <a:headEnd type="none" w="med" len="med"/>
+                      <a:tailEnd type="none" w="med" len="med"/>
+                    </a:lnL>
+                    <a:lnR w="6350" cap="flat" cmpd="sng" algn="ctr">
+                      <a:solidFill>
+                        <a:srgbClr val="ECF0F1"/>
+                      </a:solidFill>
+                      <a:prstDash val="solid"/>
+                      <a:round/>
+                      <a:headEnd type="none" w="med" len="med"/>
+                      <a:tailEnd type="none" w="med" len="med"/>
+                    </a:lnR>
+                    <a:lnT w="6350" cap="flat" cmpd="sng" algn="ctr">
+                      <a:solidFill>
+                        <a:srgbClr val="ECF0F1"/>
+                      </a:solidFill>
+                      <a:prstDash val="solid"/>
+                      <a:round/>
+                      <a:headEnd type="none" w="med" len="med"/>
+                      <a:tailEnd type="none" w="med" len="med"/>
+                    </a:lnT>
+                    <a:lnB w="6350" cap="flat" cmpd="sng" algn="ctr">
+                      <a:solidFill>
+                        <a:srgbClr val="ECF0F1"/>
+                      </a:solidFill>
+                      <a:prstDash val="solid"/>
+                      <a:round/>
+                      <a:headEnd type="none" w="med" len="med"/>
+                      <a:tailEnd type="none" w="med" len="med"/>
+                    </a:lnB>
+                  </a:tcPr>
+                </a:tc>
+                <a:tc>
+                  <a:txBody>
+                    <a:bodyPr/>
+                    <a:lstStyle/>
+                    <a:p>
+                      <a:pPr indent="0" marL="0">
+                        <a:buNone/>
+                      </a:pPr>
+                      <a:r>
+                        <a:rPr lang="en-US" sz="1100" dirty="0">
+                          <a:solidFill>
+                            <a:srgbClr val="2C3E50"/>
+                          </a:solidFill>
+                          <a:latin typeface="Calibri" pitchFamily="34" charset="0"/>
+                          <a:ea typeface="Calibri" pitchFamily="34" charset="-122"/>
+                          <a:cs typeface="Calibri" pitchFamily="34" charset="-120"/>
+                        </a:rPr>
+                        <a:t>Very High</a:t>
+                      </a:r>
+                      <a:endParaRPr lang="en-US" sz="1100" dirty="0">
+                        <a:latin typeface="Calibri" charset="0"/>
+                        <a:ea typeface="Calibri" charset="0"/>
+                        <a:cs typeface="Calibri" charset="0"/>
+                      </a:endParaRPr>
+                    </a:p>
+                  </a:txBody>
+                  <a:tcPr marL="91440" marR="91440" marT="45720" marB="45720">
+                    <a:lnL w="6350" cap="flat" cmpd="sng" algn="ctr">
+                      <a:solidFill>
+                        <a:srgbClr val="ECF0F1"/>
+                      </a:solidFill>
+                      <a:prstDash val="solid"/>
+                      <a:round/>
+                      <a:headEnd type="none" w="med" len="med"/>
+                      <a:tailEnd type="none" w="med" len="med"/>
+                    </a:lnL>
+                    <a:lnR w="6350" cap="flat" cmpd="sng" algn="ctr">
+                      <a:solidFill>
+                        <a:srgbClr val="ECF0F1"/>
+                      </a:solidFill>
+                      <a:prstDash val="solid"/>
+                      <a:round/>
+                      <a:headEnd type="none" w="med" len="med"/>
+                      <a:tailEnd type="none" w="med" len="med"/>
+                    </a:lnR>
+                    <a:lnT w="6350" cap="flat" cmpd="sng" algn="ctr">
+                      <a:solidFill>
+                        <a:srgbClr val="ECF0F1"/>
+                      </a:solidFill>
+                      <a:prstDash val="solid"/>
+                      <a:round/>
+                      <a:headEnd type="none" w="med" len="med"/>
+                      <a:tailEnd type="none" w="med" len="med"/>
+                    </a:lnT>
+                    <a:lnB w="6350" cap="flat" cmpd="sng" algn="ctr">
+                      <a:solidFill>
+                        <a:srgbClr val="ECF0F1"/>
+                      </a:solidFill>
+                      <a:prstDash val="solid"/>
+                      <a:round/>
+                      <a:headEnd type="none" w="med" len="med"/>
+                      <a:tailEnd type="none" w="med" len="med"/>
+                    </a:lnB>
+                  </a:tcPr>
+                </a:tc>
+                <a:tc>
+                  <a:txBody>
+                    <a:bodyPr/>
+                    <a:lstStyle/>
+                    <a:p>
+                      <a:pPr indent="0" marL="0">
+                        <a:buNone/>
+                      </a:pPr>
+                      <a:r>
+                        <a:rPr lang="en-US" sz="1100" dirty="0">
+                          <a:solidFill>
+                            <a:srgbClr val="2C3E50"/>
+                          </a:solidFill>
+                          <a:latin typeface="Calibri" pitchFamily="34" charset="0"/>
+                          <a:ea typeface="Calibri" pitchFamily="34" charset="-122"/>
+                          <a:cs typeface="Calibri" pitchFamily="34" charset="-120"/>
+                        </a:rPr>
+                        <a:t>Very High</a:t>
+                      </a:r>
+                      <a:endParaRPr lang="en-US" sz="1100" dirty="0">
+                        <a:latin typeface="Calibri" charset="0"/>
+                        <a:ea typeface="Calibri" charset="0"/>
+                        <a:cs typeface="Calibri" charset="0"/>
+                      </a:endParaRPr>
+                    </a:p>
+                  </a:txBody>
+                  <a:tcPr marL="91440" marR="91440" marT="45720" marB="45720">
+                    <a:lnL w="6350" cap="flat" cmpd="sng" algn="ctr">
+                      <a:solidFill>
+                        <a:srgbClr val="ECF0F1"/>
+                      </a:solidFill>
+                      <a:prstDash val="solid"/>
+                      <a:round/>
+                      <a:headEnd type="none" w="med" len="med"/>
+                      <a:tailEnd type="none" w="med" len="med"/>
+                    </a:lnL>
+                    <a:lnR w="6350" cap="flat" cmpd="sng" algn="ctr">
+                      <a:solidFill>
+                        <a:srgbClr val="ECF0F1"/>
+                      </a:solidFill>
+                      <a:prstDash val="solid"/>
+                      <a:round/>
+                      <a:headEnd type="none" w="med" len="med"/>
+                      <a:tailEnd type="none" w="med" len="med"/>
+                    </a:lnR>
+                    <a:lnT w="6350" cap="flat" cmpd="sng" algn="ctr">
+                      <a:solidFill>
+                        <a:srgbClr val="ECF0F1"/>
+                      </a:solidFill>
+                      <a:prstDash val="solid"/>
+                      <a:round/>
+                      <a:headEnd type="none" w="med" len="med"/>
+                      <a:tailEnd type="none" w="med" len="med"/>
+                    </a:lnT>
+                    <a:lnB w="6350" cap="flat" cmpd="sng" algn="ctr">
+                      <a:solidFill>
+                        <a:srgbClr val="ECF0F1"/>
+                      </a:solidFill>
+                      <a:prstDash val="solid"/>
+                      <a:round/>
+                      <a:headEnd type="none" w="med" len="med"/>
+                      <a:tailEnd type="none" w="med" len="med"/>
+                    </a:lnB>
+                  </a:tcPr>
+                </a:tc>
+                <a:tc>
+                  <a:txBody>
+                    <a:bodyPr/>
+                    <a:lstStyle/>
+                    <a:p>
+                      <a:pPr indent="0" marL="0">
+                        <a:buNone/>
+                      </a:pPr>
+                      <a:r>
+                        <a:rPr lang="en-US" sz="1100" dirty="0">
+                          <a:solidFill>
+                            <a:srgbClr val="2C3E50"/>
+                          </a:solidFill>
+                          <a:latin typeface="Calibri" pitchFamily="34" charset="0"/>
+                          <a:ea typeface="Calibri" pitchFamily="34" charset="-122"/>
+                          <a:cs typeface="Calibri" pitchFamily="34" charset="-120"/>
+                        </a:rPr>
+                        <a:t>Revit only</a:t>
+                      </a:r>
+                      <a:endParaRPr lang="en-US" sz="1100" dirty="0">
+                        <a:latin typeface="Calibri" charset="0"/>
+                        <a:ea typeface="Calibri" charset="0"/>
+                        <a:cs typeface="Calibri" charset="0"/>
+                      </a:endParaRPr>
+                    </a:p>
+                  </a:txBody>
+                  <a:tcPr marL="91440" marR="91440" marT="45720" marB="45720">
+                    <a:lnL w="6350" cap="flat" cmpd="sng" algn="ctr">
+                      <a:solidFill>
+                        <a:srgbClr val="ECF0F1"/>
+                      </a:solidFill>
+                      <a:prstDash val="solid"/>
+                      <a:round/>
+                      <a:headEnd type="none" w="med" len="med"/>
+                      <a:tailEnd type="none" w="med" len="med"/>
+                    </a:lnL>
+                    <a:lnR w="6350" cap="flat" cmpd="sng" algn="ctr">
+                      <a:solidFill>
+                        <a:srgbClr val="ECF0F1"/>
+                      </a:solidFill>
+                      <a:prstDash val="solid"/>
+                      <a:round/>
+                      <a:headEnd type="none" w="med" len="med"/>
+                      <a:tailEnd type="none" w="med" len="med"/>
+                    </a:lnR>
+                    <a:lnT w="6350" cap="flat" cmpd="sng" algn="ctr">
+                      <a:solidFill>
+                        <a:srgbClr val="ECF0F1"/>
+                      </a:solidFill>
+                      <a:prstDash val="solid"/>
+                      <a:round/>
+                      <a:headEnd type="none" w="med" len="med"/>
+                      <a:tailEnd type="none" w="med" len="med"/>
+                    </a:lnT>
+                    <a:lnB w="6350" cap="flat" cmpd="sng" algn="ctr">
+                      <a:solidFill>
+                        <a:srgbClr val="ECF0F1"/>
+                      </a:solidFill>
+                      <a:prstDash val="solid"/>
+                      <a:round/>
+                      <a:headEnd type="none" w="med" len="med"/>
+                      <a:tailEnd type="none" w="med" len="med"/>
+                    </a:lnB>
+                  </a:tcPr>
+                </a:tc>
+              </a:tr>
+            </a:tbl>
+          </a:graphicData>
+        </a:graphic>
+      </p:graphicFrame>
+      <p:sp>
+        <p:nvSpPr>
+          <p:cNvPr id="8" name="Shape 5"/>
+          <p:cNvSpPr/>
+          <p:nvPr/>
+        </p:nvSpPr>
+        <p:spPr>
+          <a:xfrm>
+            <a:off x="457200" y="3886200"/>
+            <a:ext cx="8229600" cy="1005840"/>
+          </a:xfrm>
+          <a:prstGeom prst="rect">
+            <a:avLst/>
+          </a:prstGeom>
+          <a:solidFill>
+            <a:srgbClr val="0F1923"/>
+          </a:solidFill>
+          <a:ln/>
+          <a:effectLst>
+            <a:outerShdw sx="100000" sy="100000" kx="0" ky="0" algn="bl" rotWithShape="0" blurRad="76200" dist="25400" dir="8100000">
+              <a:srgbClr val="000000">
+                <a:alpha val="15000"/>
+              </a:srgbClr>
+            </a:outerShdw>
+          </a:effectLst>
+        </p:spPr>
+      </p:sp>
+      <p:sp>
+        <p:nvSpPr>
+          <p:cNvPr id="9" name="Text 6"/>
+          <p:cNvSpPr/>
+          <p:nvPr/>
+        </p:nvSpPr>
+        <p:spPr>
+          <a:xfrm>
+            <a:off x="640080" y="3977640"/>
+            <a:ext cx="7863840" cy="365760"/>
+          </a:xfrm>
+          <a:prstGeom prst="rect">
+            <a:avLst/>
+          </a:prstGeom>
+          <a:noFill/>
+          <a:ln/>
+        </p:spPr>
+        <p:txBody>
+          <a:bodyPr wrap="square" lIns="0" tIns="0" rIns="0" bIns="0" rtlCol="0" anchor="ctr"/>
+          <a:lstStyle/>
+          <a:p>
+            <a:pPr algn="ctr" indent="0" marL="0">
+              <a:buNone/>
             </a:pPr>
             <a:r>
               <a:rPr lang="en-US" sz="1200" dirty="0">
                 <a:solidFill>
-                  <a:srgbClr val="2C3E50"/>
-                </a:solidFill>
-                <a:latin typeface="Calibri" pitchFamily="34" charset="0"/>
-                <a:ea typeface="Calibri" pitchFamily="34" charset="-122"/>
-                <a:cs typeface="Calibri" pitchFamily="34" charset="-120"/>
-              </a:rPr>
-              <a:t>Working prototype (Docker Compose, live at resuceforge.skimu.de)</a:t>
+                  <a:srgbClr val="F39C12"/>
+                </a:solidFill>
+                <a:latin typeface="Calibri" pitchFamily="34" charset="0"/>
+                <a:ea typeface="Calibri" pitchFamily="34" charset="-122"/>
+                <a:cs typeface="Calibri" pitchFamily="34" charset="-120"/>
+              </a:rPr>
+              <a:t>Plugin Architecture: AutoCAD  →  Export DXF  →  POST /api/upload  →  WS Progress  →  Download PDF</a:t>
             </a:r>
             <a:endParaRPr lang="en-US" sz="1200" dirty="0"/>
           </a:p>
-          <a:p>
-            <a:pPr marL="342900" indent="-342900">
-              <a:spcAft>
-                <a:spcPts val="300"/>
-              </a:spcAft>
-              <a:buSzPct val="100000"/>
-              <a:buChar char="•"/>
-            </a:pPr>
-            <a:r>
-              <a:rPr lang="en-US" sz="1200" dirty="0">
-                <a:solidFill>
-                  <a:srgbClr val="2C3E50"/>
-                </a:solidFill>
-                <a:latin typeface="Calibri" pitchFamily="34" charset="0"/>
-                <a:ea typeface="Calibri" pitchFamily="34" charset="-122"/>
-                <a:cs typeface="Calibri" pitchFamily="34" charset="-120"/>
-              </a:rPr>
-              <a:t>AI-powered room classification (Gemini 2.5 Flash Vision API)</a:t>
-            </a:r>
-            <a:endParaRPr lang="en-US" sz="1200" dirty="0"/>
-          </a:p>
-          <a:p>
-            <a:pPr marL="342900" indent="-342900">
-              <a:spcAft>
-                <a:spcPts val="300"/>
-              </a:spcAft>
-              <a:buSzPct val="100000"/>
-              <a:buChar char="•"/>
-            </a:pPr>
-            <a:r>
-              <a:rPr lang="en-US" sz="1200" dirty="0">
-                <a:solidFill>
-                  <a:srgbClr val="2C3E50"/>
-                </a:solidFill>
-                <a:latin typeface="Calibri" pitchFamily="34" charset="0"/>
-                <a:ea typeface="Calibri" pitchFamily="34" charset="-122"/>
-                <a:cs typeface="Calibri" pitchFamily="34" charset="-120"/>
-              </a:rPr>
-              <a:t>DIN 14095 / FKS-compliant plan output (SVG + PDF)</a:t>
-            </a:r>
-            <a:endParaRPr lang="en-US" sz="1200" dirty="0"/>
-          </a:p>
-          <a:p>
-            <a:pPr marL="342900" indent="-342900">
-              <a:spcAft>
-                <a:spcPts val="300"/>
-              </a:spcAft>
-              <a:buSzPct val="100000"/>
-              <a:buChar char="•"/>
-            </a:pPr>
-            <a:r>
-              <a:rPr lang="en-US" sz="1200" dirty="0">
-                <a:solidFill>
-                  <a:srgbClr val="2C3E50"/>
-                </a:solidFill>
-                <a:latin typeface="Calibri" pitchFamily="34" charset="0"/>
-                <a:ea typeface="Calibri" pitchFamily="34" charset="-122"/>
-                <a:cs typeface="Calibri" pitchFamily="34" charset="-120"/>
-              </a:rPr>
-              <a:t>Complete plan set: Floor plan + Cover sheet + Situation plan + Compliance report</a:t>
-            </a:r>
-            <a:endParaRPr lang="en-US" sz="1200" dirty="0"/>
-          </a:p>
-          <a:p>
-            <a:pPr marL="342900" indent="-342900">
-              <a:spcAft>
-                <a:spcPts val="300"/>
-              </a:spcAft>
-              <a:buSzPct val="100000"/>
-              <a:buChar char="•"/>
-            </a:pPr>
-            <a:r>
-              <a:rPr lang="en-US" sz="1200" dirty="0">
-                <a:solidFill>
-                  <a:srgbClr val="2C3E50"/>
-                </a:solidFill>
-                <a:latin typeface="Calibri" pitchFamily="34" charset="0"/>
-                <a:ea typeface="Calibri" pitchFamily="34" charset="-122"/>
-                <a:cs typeface="Calibri" pitchFamily="34" charset="-120"/>
-              </a:rPr>
-              <a:t>Interactive room editor with live regeneration</a:t>
-            </a:r>
-            <a:endParaRPr lang="en-US" sz="1200" dirty="0"/>
-          </a:p>
-          <a:p>
-            <a:pPr marL="342900" indent="-342900">
-              <a:spcAft>
-                <a:spcPts val="300"/>
-              </a:spcAft>
-              <a:buSzPct val="100000"/>
-              <a:buChar char="•"/>
-            </a:pPr>
-            <a:r>
-              <a:rPr lang="en-US" sz="1200" dirty="0">
-                <a:solidFill>
-                  <a:srgbClr val="2C3E50"/>
-                </a:solidFill>
-                <a:latin typeface="Calibri" pitchFamily="34" charset="0"/>
-                <a:ea typeface="Calibri" pitchFamily="34" charset="-122"/>
-                <a:cs typeface="Calibri" pitchFamily="34" charset="-120"/>
-              </a:rPr>
-              <a:t>Batch upload for multi-floor processing</a:t>
-            </a:r>
-            <a:endParaRPr lang="en-US" sz="1200" dirty="0"/>
-          </a:p>
-          <a:p>
-            <a:pPr marL="342900" indent="-342900">
-              <a:spcAft>
-                <a:spcPts val="300"/>
-              </a:spcAft>
-              <a:buSzPct val="100000"/>
-              <a:buChar char="•"/>
-            </a:pPr>
-            <a:r>
-              <a:rPr lang="en-US" sz="1200" dirty="0">
-                <a:solidFill>
-                  <a:srgbClr val="2C3E50"/>
-                </a:solidFill>
-                <a:latin typeface="Calibri" pitchFamily="34" charset="0"/>
-                <a:ea typeface="Calibri" pitchFamily="34" charset="-122"/>
-                <a:cs typeface="Calibri" pitchFamily="34" charset="-120"/>
-              </a:rPr>
-              <a:t>328+ automated tests (19 suites) + Cypress E2E</a:t>
-            </a:r>
-            <a:endParaRPr lang="en-US" sz="1200" dirty="0"/>
-          </a:p>
-          <a:p>
-            <a:pPr marL="342900" indent="-342900">
-              <a:spcAft>
-                <a:spcPts val="300"/>
-              </a:spcAft>
-              <a:buSzPct val="100000"/>
-              <a:buChar char="•"/>
-            </a:pPr>
-            <a:r>
-              <a:rPr lang="en-US" sz="1200" dirty="0">
-                <a:solidFill>
-                  <a:srgbClr val="2C3E50"/>
-                </a:solidFill>
-                <a:latin typeface="Calibri" pitchFamily="34" charset="0"/>
-                <a:ea typeface="Calibri" pitchFamily="34" charset="-122"/>
-                <a:cs typeface="Calibri" pitchFamily="34" charset="-120"/>
-              </a:rPr>
-              <a:t>CI/CD pipeline (GitHub Actions)</a:t>
-            </a:r>
-            <a:endParaRPr lang="en-US" sz="1200" dirty="0"/>
-          </a:p>
-          <a:p>
-            <a:pPr marL="342900" indent="-342900">
-              <a:spcAft>
-                <a:spcPts val="300"/>
-              </a:spcAft>
-              <a:buSzPct val="100000"/>
-              <a:buChar char="•"/>
-            </a:pPr>
-            <a:r>
-              <a:rPr lang="en-US" sz="1200" dirty="0">
-                <a:solidFill>
-                  <a:srgbClr val="2C3E50"/>
-                </a:solidFill>
-                <a:latin typeface="Calibri" pitchFamily="34" charset="0"/>
-                <a:ea typeface="Calibri" pitchFamily="34" charset="-122"/>
-                <a:cs typeface="Calibri" pitchFamily="34" charset="-120"/>
-              </a:rPr>
-              <a:t>Multi-language support (EN/DE)</a:t>
-            </a:r>
-            <a:endParaRPr lang="en-US" sz="1200" dirty="0"/>
-          </a:p>
-          <a:p>
-            <a:pPr marL="342900" indent="-342900">
-              <a:spcAft>
-                <a:spcPts val="300"/>
-              </a:spcAft>
-              <a:buSzPct val="100000"/>
-              <a:buChar char="•"/>
-            </a:pPr>
-            <a:r>
-              <a:rPr lang="en-US" sz="1200" dirty="0">
-                <a:solidFill>
-                  <a:srgbClr val="2C3E50"/>
-                </a:solidFill>
-                <a:latin typeface="Calibri" pitchFamily="34" charset="0"/>
-                <a:ea typeface="Calibri" pitchFamily="34" charset="-122"/>
-                <a:cs typeface="Calibri" pitchFamily="34" charset="-120"/>
-              </a:rPr>
-              <a:t>Corridor-centerline escape routes (Voronoi + NetworkX)</a:t>
-            </a:r>
-            <a:endParaRPr lang="en-US" sz="1200" dirty="0"/>
-          </a:p>
-          <a:p>
-            <a:pPr marL="342900" indent="-342900">
-              <a:spcAft>
-                <a:spcPts val="300"/>
-              </a:spcAft>
-              <a:buSzPct val="100000"/>
-              <a:buChar char="•"/>
-            </a:pPr>
-            <a:r>
-              <a:rPr lang="en-US" sz="1200" dirty="0">
-                <a:solidFill>
-                  <a:srgbClr val="2C3E50"/>
-                </a:solidFill>
-                <a:latin typeface="Calibri" pitchFamily="34" charset="0"/>
-                <a:ea typeface="Calibri" pitchFamily="34" charset="-122"/>
-                <a:cs typeface="Calibri" pitchFamily="34" charset="-120"/>
-              </a:rPr>
-              <a:t>Symbol collision avoidance + fire safety element recognition</a:t>
-            </a:r>
-            <a:endParaRPr lang="en-US" sz="1200" dirty="0"/>
-          </a:p>
-          <a:p>
-            <a:pPr marL="342900" indent="-342900">
-              <a:spcAft>
-                <a:spcPts val="300"/>
-              </a:spcAft>
-              <a:buSzPct val="100000"/>
-              <a:buChar char="•"/>
-            </a:pPr>
-            <a:r>
-              <a:rPr lang="en-US" sz="1200" dirty="0">
-                <a:solidFill>
-                  <a:srgbClr val="2C3E50"/>
-                </a:solidFill>
-                <a:latin typeface="Calibri" pitchFamily="34" charset="0"/>
-                <a:ea typeface="Calibri" pitchFamily="34" charset="-122"/>
-                <a:cs typeface="Calibri" pitchFamily="34" charset="-120"/>
-              </a:rPr>
-              <a:t>DIN-standard scale detection (1:50 to 1:1000)</a:t>
-            </a:r>
-            <a:endParaRPr lang="en-US" sz="1200" dirty="0"/>
+        </p:txBody>
+      </p:sp>
+      <p:sp>
+        <p:nvSpPr>
+          <p:cNvPr id="10" name="Text 7"/>
+          <p:cNvSpPr/>
+          <p:nvPr/>
+        </p:nvSpPr>
+        <p:spPr>
+          <a:xfrm>
+            <a:off x="640080" y="4389120"/>
+            <a:ext cx="7863840" cy="320040"/>
+          </a:xfrm>
+          <a:prstGeom prst="rect">
+            <a:avLst/>
+          </a:prstGeom>
+          <a:noFill/>
+          <a:ln/>
+        </p:spPr>
+        <p:txBody>
+          <a:bodyPr wrap="square" lIns="0" tIns="0" rIns="0" bIns="0" rtlCol="0" anchor="ctr"/>
+          <a:lstStyle/>
+          <a:p>
+            <a:pPr algn="ctr" indent="0" marL="0">
+              <a:buNone/>
+            </a:pPr>
+            <a:r>
+              <a:rPr lang="en-US" sz="1100" i="1" dirty="0">
+                <a:solidFill>
+                  <a:srgbClr val="95A5A6"/>
+                </a:solidFill>
+                <a:latin typeface="Calibri" pitchFamily="34" charset="0"/>
+                <a:ea typeface="Calibri" pitchFamily="34" charset="-122"/>
+                <a:cs typeface="Calibri" pitchFamily="34" charset="-120"/>
+              </a:rPr>
+              <a:t>Same API  ·  Same Pipeline  ·  Same Results  ·  Plugin is a 200-line C# wrapper</a:t>
+            </a:r>
+            <a:endParaRPr lang="en-US" sz="1100" dirty="0"/>
+          </a:p>
+        </p:txBody>
+      </p:sp>
+      <p:sp>
+        <p:nvSpPr>
+          <p:cNvPr id="11" name="Text 8"/>
+          <p:cNvSpPr/>
+          <p:nvPr/>
+        </p:nvSpPr>
+        <p:spPr>
+          <a:xfrm>
+            <a:off x="7772400" y="4800600"/>
+            <a:ext cx="1097280" cy="274320"/>
+          </a:xfrm>
+          <a:prstGeom prst="rect">
+            <a:avLst/>
+          </a:prstGeom>
+          <a:noFill/>
+          <a:ln/>
+        </p:spPr>
+        <p:txBody>
+          <a:bodyPr wrap="square" lIns="0" tIns="0" rIns="0" bIns="0" rtlCol="0" anchor="ctr"/>
+          <a:lstStyle/>
+          <a:p>
+            <a:pPr algn="r" indent="0" marL="0">
+              <a:buNone/>
+            </a:pPr>
+            <a:r>
+              <a:rPr lang="en-US" sz="800" dirty="0">
+                <a:solidFill>
+                  <a:srgbClr val="95A5A6"/>
+                </a:solidFill>
+                <a:latin typeface="Calibri" pitchFamily="34" charset="0"/>
+                <a:ea typeface="Calibri" pitchFamily="34" charset="-122"/>
+                <a:cs typeface="Calibri" pitchFamily="34" charset="-120"/>
+              </a:rPr>
+              <a:t>13 / 15</a:t>
+            </a:r>
+            <a:endParaRPr lang="en-US" sz="800" dirty="0"/>
           </a:p>
         </p:txBody>
       </p:sp>
@@ -5413,6 +6667,410 @@
 <file path=ppt/slides/slide14.xml><?xml version="1.0" encoding="utf-8"?>
 <p:sld xmlns:a="http://schemas.openxmlformats.org/drawingml/2006/main" xmlns:r="http://schemas.openxmlformats.org/officeDocument/2006/relationships" xmlns:p="http://schemas.openxmlformats.org/presentationml/2006/main">
   <p:cSld name="Slide 14">
+    <p:bg>
+      <p:bgPr>
+        <a:solidFill>
+          <a:srgbClr val="F8F9FA"/>
+        </a:solidFill>
+      </p:bgPr>
+    </p:bg>
+    <p:spTree>
+      <p:nvGrpSpPr>
+        <p:cNvPr id="1" name=""/>
+        <p:cNvGrpSpPr/>
+        <p:nvPr/>
+      </p:nvGrpSpPr>
+      <p:grpSpPr>
+        <a:xfrm>
+          <a:off x="0" y="0"/>
+          <a:ext cx="0" cy="0"/>
+          <a:chOff x="0" y="0"/>
+          <a:chExt cx="0" cy="0"/>
+        </a:xfrm>
+      </p:grpSpPr>
+      <p:sp>
+        <p:nvSpPr>
+          <p:cNvPr id="2" name="Shape 0"/>
+          <p:cNvSpPr/>
+          <p:nvPr/>
+        </p:nvSpPr>
+        <p:spPr>
+          <a:xfrm>
+            <a:off x="0" y="0"/>
+            <a:ext cx="9144000" cy="914400"/>
+          </a:xfrm>
+          <a:prstGeom prst="rect">
+            <a:avLst/>
+          </a:prstGeom>
+          <a:solidFill>
+            <a:srgbClr val="27AE60"/>
+          </a:solidFill>
+          <a:ln/>
+        </p:spPr>
+      </p:sp>
+      <p:sp>
+        <p:nvSpPr>
+          <p:cNvPr id="3" name="Text 1"/>
+          <p:cNvSpPr/>
+          <p:nvPr/>
+        </p:nvSpPr>
+        <p:spPr>
+          <a:xfrm>
+            <a:off x="548640" y="137160"/>
+            <a:ext cx="7315200" cy="640080"/>
+          </a:xfrm>
+          <a:prstGeom prst="rect">
+            <a:avLst/>
+          </a:prstGeom>
+          <a:noFill/>
+          <a:ln/>
+        </p:spPr>
+        <p:txBody>
+          <a:bodyPr wrap="square" lIns="0" tIns="0" rIns="0" bIns="0" rtlCol="0" anchor="ctr"/>
+          <a:lstStyle/>
+          <a:p>
+            <a:pPr indent="0" marL="0">
+              <a:buNone/>
+            </a:pPr>
+            <a:r>
+              <a:rPr lang="en-US" sz="2800" b="1" dirty="0">
+                <a:solidFill>
+                  <a:srgbClr val="FFFFFF"/>
+                </a:solidFill>
+                <a:latin typeface="Arial Black" pitchFamily="34" charset="0"/>
+                <a:ea typeface="Arial Black" pitchFamily="34" charset="-122"/>
+                <a:cs typeface="Arial Black" pitchFamily="34" charset="-120"/>
+              </a:rPr>
+              <a:t>Hackathon Deliverables</a:t>
+            </a:r>
+            <a:endParaRPr lang="en-US" sz="2800" dirty="0"/>
+          </a:p>
+        </p:txBody>
+      </p:sp>
+      <p:sp>
+        <p:nvSpPr>
+          <p:cNvPr id="4" name="Text 2"/>
+          <p:cNvSpPr/>
+          <p:nvPr/>
+        </p:nvSpPr>
+        <p:spPr>
+          <a:xfrm>
+            <a:off x="731520" y="1097280"/>
+            <a:ext cx="7680960" cy="3840480"/>
+          </a:xfrm>
+          <a:prstGeom prst="rect">
+            <a:avLst/>
+          </a:prstGeom>
+          <a:noFill/>
+          <a:ln/>
+        </p:spPr>
+        <p:txBody>
+          <a:bodyPr wrap="square" lIns="0" tIns="0" rIns="0" bIns="0" rtlCol="0" anchor="ctr"/>
+          <a:lstStyle/>
+          <a:p>
+            <a:pPr marL="342900" indent="-342900">
+              <a:spcAft>
+                <a:spcPts val="300"/>
+              </a:spcAft>
+              <a:buSzPct val="100000"/>
+              <a:buChar char="•"/>
+            </a:pPr>
+            <a:r>
+              <a:rPr lang="en-US" sz="1200" dirty="0">
+                <a:solidFill>
+                  <a:srgbClr val="2C3E50"/>
+                </a:solidFill>
+                <a:latin typeface="Calibri" pitchFamily="34" charset="0"/>
+                <a:ea typeface="Calibri" pitchFamily="34" charset="-122"/>
+                <a:cs typeface="Calibri" pitchFamily="34" charset="-120"/>
+              </a:rPr>
+              <a:t>Working prototype (Docker Compose, live at rescueforge.skimu.de)</a:t>
+            </a:r>
+            <a:endParaRPr lang="en-US" sz="1200" dirty="0"/>
+          </a:p>
+          <a:p>
+            <a:pPr marL="342900" indent="-342900">
+              <a:spcAft>
+                <a:spcPts val="300"/>
+              </a:spcAft>
+              <a:buSzPct val="100000"/>
+              <a:buChar char="•"/>
+            </a:pPr>
+            <a:r>
+              <a:rPr lang="en-US" sz="1200" dirty="0">
+                <a:solidFill>
+                  <a:srgbClr val="2C3E50"/>
+                </a:solidFill>
+                <a:latin typeface="Calibri" pitchFamily="34" charset="0"/>
+                <a:ea typeface="Calibri" pitchFamily="34" charset="-122"/>
+                <a:cs typeface="Calibri" pitchFamily="34" charset="-120"/>
+              </a:rPr>
+              <a:t>AI-powered room classification (Gemini 2.5 Flash Vision API)</a:t>
+            </a:r>
+            <a:endParaRPr lang="en-US" sz="1200" dirty="0"/>
+          </a:p>
+          <a:p>
+            <a:pPr marL="342900" indent="-342900">
+              <a:spcAft>
+                <a:spcPts val="300"/>
+              </a:spcAft>
+              <a:buSzPct val="100000"/>
+              <a:buChar char="•"/>
+            </a:pPr>
+            <a:r>
+              <a:rPr lang="en-US" sz="1200" dirty="0">
+                <a:solidFill>
+                  <a:srgbClr val="2C3E50"/>
+                </a:solidFill>
+                <a:latin typeface="Calibri" pitchFamily="34" charset="0"/>
+                <a:ea typeface="Calibri" pitchFamily="34" charset="-122"/>
+                <a:cs typeface="Calibri" pitchFamily="34" charset="-120"/>
+              </a:rPr>
+              <a:t>DIN 14095 / FKS-compliant plan output (SVG + PDF)</a:t>
+            </a:r>
+            <a:endParaRPr lang="en-US" sz="1200" dirty="0"/>
+          </a:p>
+          <a:p>
+            <a:pPr marL="342900" indent="-342900">
+              <a:spcAft>
+                <a:spcPts val="300"/>
+              </a:spcAft>
+              <a:buSzPct val="100000"/>
+              <a:buChar char="•"/>
+            </a:pPr>
+            <a:r>
+              <a:rPr lang="en-US" sz="1200" dirty="0">
+                <a:solidFill>
+                  <a:srgbClr val="2C3E50"/>
+                </a:solidFill>
+                <a:latin typeface="Calibri" pitchFamily="34" charset="0"/>
+                <a:ea typeface="Calibri" pitchFamily="34" charset="-122"/>
+                <a:cs typeface="Calibri" pitchFamily="34" charset="-120"/>
+              </a:rPr>
+              <a:t>Complete plan set: Floor plan + Cover sheet + Situation plan + Compliance report</a:t>
+            </a:r>
+            <a:endParaRPr lang="en-US" sz="1200" dirty="0"/>
+          </a:p>
+          <a:p>
+            <a:pPr marL="342900" indent="-342900">
+              <a:spcAft>
+                <a:spcPts val="300"/>
+              </a:spcAft>
+              <a:buSzPct val="100000"/>
+              <a:buChar char="•"/>
+            </a:pPr>
+            <a:r>
+              <a:rPr lang="en-US" sz="1200" dirty="0">
+                <a:solidFill>
+                  <a:srgbClr val="2C3E50"/>
+                </a:solidFill>
+                <a:latin typeface="Calibri" pitchFamily="34" charset="0"/>
+                <a:ea typeface="Calibri" pitchFamily="34" charset="-122"/>
+                <a:cs typeface="Calibri" pitchFamily="34" charset="-120"/>
+              </a:rPr>
+              <a:t>Interactive room editor with live regeneration</a:t>
+            </a:r>
+            <a:endParaRPr lang="en-US" sz="1200" dirty="0"/>
+          </a:p>
+          <a:p>
+            <a:pPr marL="342900" indent="-342900">
+              <a:spcAft>
+                <a:spcPts val="300"/>
+              </a:spcAft>
+              <a:buSzPct val="100000"/>
+              <a:buChar char="•"/>
+            </a:pPr>
+            <a:r>
+              <a:rPr lang="en-US" sz="1200" dirty="0">
+                <a:solidFill>
+                  <a:srgbClr val="2C3E50"/>
+                </a:solidFill>
+                <a:latin typeface="Calibri" pitchFamily="34" charset="0"/>
+                <a:ea typeface="Calibri" pitchFamily="34" charset="-122"/>
+                <a:cs typeface="Calibri" pitchFamily="34" charset="-120"/>
+              </a:rPr>
+              <a:t>Batch upload for multi-floor processing</a:t>
+            </a:r>
+            <a:endParaRPr lang="en-US" sz="1200" dirty="0"/>
+          </a:p>
+          <a:p>
+            <a:pPr marL="342900" indent="-342900">
+              <a:spcAft>
+                <a:spcPts val="300"/>
+              </a:spcAft>
+              <a:buSzPct val="100000"/>
+              <a:buChar char="•"/>
+            </a:pPr>
+            <a:r>
+              <a:rPr lang="en-US" sz="1200" dirty="0">
+                <a:solidFill>
+                  <a:srgbClr val="2C3E50"/>
+                </a:solidFill>
+                <a:latin typeface="Calibri" pitchFamily="34" charset="0"/>
+                <a:ea typeface="Calibri" pitchFamily="34" charset="-122"/>
+                <a:cs typeface="Calibri" pitchFamily="34" charset="-120"/>
+              </a:rPr>
+              <a:t>328+ automated tests (19 suites) + Cypress E2E</a:t>
+            </a:r>
+            <a:endParaRPr lang="en-US" sz="1200" dirty="0"/>
+          </a:p>
+          <a:p>
+            <a:pPr marL="342900" indent="-342900">
+              <a:spcAft>
+                <a:spcPts val="300"/>
+              </a:spcAft>
+              <a:buSzPct val="100000"/>
+              <a:buChar char="•"/>
+            </a:pPr>
+            <a:r>
+              <a:rPr lang="en-US" sz="1200" dirty="0">
+                <a:solidFill>
+                  <a:srgbClr val="2C3E50"/>
+                </a:solidFill>
+                <a:latin typeface="Calibri" pitchFamily="34" charset="0"/>
+                <a:ea typeface="Calibri" pitchFamily="34" charset="-122"/>
+                <a:cs typeface="Calibri" pitchFamily="34" charset="-120"/>
+              </a:rPr>
+              <a:t>CI/CD pipeline (GitHub Actions)</a:t>
+            </a:r>
+            <a:endParaRPr lang="en-US" sz="1200" dirty="0"/>
+          </a:p>
+          <a:p>
+            <a:pPr marL="342900" indent="-342900">
+              <a:spcAft>
+                <a:spcPts val="300"/>
+              </a:spcAft>
+              <a:buSzPct val="100000"/>
+              <a:buChar char="•"/>
+            </a:pPr>
+            <a:r>
+              <a:rPr lang="en-US" sz="1200" dirty="0">
+                <a:solidFill>
+                  <a:srgbClr val="2C3E50"/>
+                </a:solidFill>
+                <a:latin typeface="Calibri" pitchFamily="34" charset="0"/>
+                <a:ea typeface="Calibri" pitchFamily="34" charset="-122"/>
+                <a:cs typeface="Calibri" pitchFamily="34" charset="-120"/>
+              </a:rPr>
+              <a:t>Multi-language support (EN/DE)</a:t>
+            </a:r>
+            <a:endParaRPr lang="en-US" sz="1200" dirty="0"/>
+          </a:p>
+          <a:p>
+            <a:pPr marL="342900" indent="-342900">
+              <a:spcAft>
+                <a:spcPts val="300"/>
+              </a:spcAft>
+              <a:buSzPct val="100000"/>
+              <a:buChar char="•"/>
+            </a:pPr>
+            <a:r>
+              <a:rPr lang="en-US" sz="1200" dirty="0">
+                <a:solidFill>
+                  <a:srgbClr val="2C3E50"/>
+                </a:solidFill>
+                <a:latin typeface="Calibri" pitchFamily="34" charset="0"/>
+                <a:ea typeface="Calibri" pitchFamily="34" charset="-122"/>
+                <a:cs typeface="Calibri" pitchFamily="34" charset="-120"/>
+              </a:rPr>
+              <a:t>Corridor-centerline escape routes (Voronoi + NetworkX)</a:t>
+            </a:r>
+            <a:endParaRPr lang="en-US" sz="1200" dirty="0"/>
+          </a:p>
+          <a:p>
+            <a:pPr marL="342900" indent="-342900">
+              <a:spcAft>
+                <a:spcPts val="300"/>
+              </a:spcAft>
+              <a:buSzPct val="100000"/>
+              <a:buChar char="•"/>
+            </a:pPr>
+            <a:r>
+              <a:rPr lang="en-US" sz="1200" dirty="0">
+                <a:solidFill>
+                  <a:srgbClr val="2C3E50"/>
+                </a:solidFill>
+                <a:latin typeface="Calibri" pitchFamily="34" charset="0"/>
+                <a:ea typeface="Calibri" pitchFamily="34" charset="-122"/>
+                <a:cs typeface="Calibri" pitchFamily="34" charset="-120"/>
+              </a:rPr>
+              <a:t>Symbol collision avoidance + fire safety element recognition</a:t>
+            </a:r>
+            <a:endParaRPr lang="en-US" sz="1200" dirty="0"/>
+          </a:p>
+          <a:p>
+            <a:pPr marL="342900" indent="-342900">
+              <a:spcAft>
+                <a:spcPts val="300"/>
+              </a:spcAft>
+              <a:buSzPct val="100000"/>
+              <a:buChar char="•"/>
+            </a:pPr>
+            <a:r>
+              <a:rPr lang="en-US" sz="1200" dirty="0">
+                <a:solidFill>
+                  <a:srgbClr val="2C3E50"/>
+                </a:solidFill>
+                <a:latin typeface="Calibri" pitchFamily="34" charset="0"/>
+                <a:ea typeface="Calibri" pitchFamily="34" charset="-122"/>
+                <a:cs typeface="Calibri" pitchFamily="34" charset="-120"/>
+              </a:rPr>
+              <a:t>DIN-standard scale detection (1:50 to 1:1000)</a:t>
+            </a:r>
+            <a:endParaRPr lang="en-US" sz="1200" dirty="0"/>
+          </a:p>
+        </p:txBody>
+      </p:sp>
+      <p:sp>
+        <p:nvSpPr>
+          <p:cNvPr id="5" name="Text 3"/>
+          <p:cNvSpPr/>
+          <p:nvPr/>
+        </p:nvSpPr>
+        <p:spPr>
+          <a:xfrm>
+            <a:off x="7772400" y="4800600"/>
+            <a:ext cx="1097280" cy="274320"/>
+          </a:xfrm>
+          <a:prstGeom prst="rect">
+            <a:avLst/>
+          </a:prstGeom>
+          <a:noFill/>
+          <a:ln/>
+        </p:spPr>
+        <p:txBody>
+          <a:bodyPr wrap="square" lIns="0" tIns="0" rIns="0" bIns="0" rtlCol="0" anchor="ctr"/>
+          <a:lstStyle/>
+          <a:p>
+            <a:pPr algn="r" indent="0" marL="0">
+              <a:buNone/>
+            </a:pPr>
+            <a:r>
+              <a:rPr lang="en-US" sz="800" dirty="0">
+                <a:solidFill>
+                  <a:srgbClr val="95A5A6"/>
+                </a:solidFill>
+                <a:latin typeface="Calibri" pitchFamily="34" charset="0"/>
+                <a:ea typeface="Calibri" pitchFamily="34" charset="-122"/>
+                <a:cs typeface="Calibri" pitchFamily="34" charset="-120"/>
+              </a:rPr>
+              <a:t>14 / 15</a:t>
+            </a:r>
+            <a:endParaRPr lang="en-US" sz="800" dirty="0"/>
+          </a:p>
+        </p:txBody>
+      </p:sp>
+    </p:spTree>
+  </p:cSld>
+  <p:clrMapOvr>
+    <a:masterClrMapping/>
+  </p:clrMapOvr>
+</p:sld>
+</file>
+
+<file path=ppt/slides/slide15.xml><?xml version="1.0" encoding="utf-8"?>
+<p:sld xmlns:a="http://schemas.openxmlformats.org/drawingml/2006/main" xmlns:r="http://schemas.openxmlformats.org/officeDocument/2006/relationships" xmlns:p="http://schemas.openxmlformats.org/presentationml/2006/main">
+  <p:cSld name="Slide 15">
     <p:bg>
       <p:bgPr>
         <a:solidFill>
@@ -5629,7 +7287,7 @@
                 <a:ea typeface="Calibri" pitchFamily="34" charset="-122"/>
                 <a:cs typeface="Calibri" pitchFamily="34" charset="-120"/>
               </a:rPr>
-              <a:t>resuceforge.skimu.de</a:t>
+              <a:t>rescueforge.skimu.de</a:t>
             </a:r>
             <a:endParaRPr lang="en-US" sz="1400" dirty="0"/>
           </a:p>
@@ -6378,6 +8036,45 @@
           </a:p>
         </p:txBody>
       </p:sp>
+      <p:sp>
+        <p:nvSpPr>
+          <p:cNvPr id="25" name="Text 20"/>
+          <p:cNvSpPr/>
+          <p:nvPr/>
+        </p:nvSpPr>
+        <p:spPr>
+          <a:xfrm>
+            <a:off x="7772400" y="4800600"/>
+            <a:ext cx="1097280" cy="274320"/>
+          </a:xfrm>
+          <a:prstGeom prst="rect">
+            <a:avLst/>
+          </a:prstGeom>
+          <a:noFill/>
+          <a:ln/>
+        </p:spPr>
+        <p:txBody>
+          <a:bodyPr wrap="square" lIns="0" tIns="0" rIns="0" bIns="0" rtlCol="0" anchor="ctr"/>
+          <a:lstStyle/>
+          <a:p>
+            <a:pPr algn="r" indent="0" marL="0">
+              <a:buNone/>
+            </a:pPr>
+            <a:r>
+              <a:rPr lang="en-US" sz="800" dirty="0">
+                <a:solidFill>
+                  <a:srgbClr val="95A5A6"/>
+                </a:solidFill>
+                <a:latin typeface="Calibri" pitchFamily="34" charset="0"/>
+                <a:ea typeface="Calibri" pitchFamily="34" charset="-122"/>
+                <a:cs typeface="Calibri" pitchFamily="34" charset="-120"/>
+              </a:rPr>
+              <a:t>2 / 15</a:t>
+            </a:r>
+            <a:endParaRPr lang="en-US" sz="800" dirty="0"/>
+          </a:p>
+        </p:txBody>
+      </p:sp>
     </p:spTree>
   </p:cSld>
   <p:clrMapOvr>
@@ -7156,6 +8853,45 @@
           </a:p>
         </p:txBody>
       </p:sp>
+      <p:sp>
+        <p:nvSpPr>
+          <p:cNvPr id="24" name="Text 19"/>
+          <p:cNvSpPr/>
+          <p:nvPr/>
+        </p:nvSpPr>
+        <p:spPr>
+          <a:xfrm>
+            <a:off x="7772400" y="4800600"/>
+            <a:ext cx="1097280" cy="274320"/>
+          </a:xfrm>
+          <a:prstGeom prst="rect">
+            <a:avLst/>
+          </a:prstGeom>
+          <a:noFill/>
+          <a:ln/>
+        </p:spPr>
+        <p:txBody>
+          <a:bodyPr wrap="square" lIns="0" tIns="0" rIns="0" bIns="0" rtlCol="0" anchor="ctr"/>
+          <a:lstStyle/>
+          <a:p>
+            <a:pPr algn="r" indent="0" marL="0">
+              <a:buNone/>
+            </a:pPr>
+            <a:r>
+              <a:rPr lang="en-US" sz="800" dirty="0">
+                <a:solidFill>
+                  <a:srgbClr val="95A5A6"/>
+                </a:solidFill>
+                <a:latin typeface="Calibri" pitchFamily="34" charset="0"/>
+                <a:ea typeface="Calibri" pitchFamily="34" charset="-122"/>
+                <a:cs typeface="Calibri" pitchFamily="34" charset="-120"/>
+              </a:rPr>
+              <a:t>3 / 15</a:t>
+            </a:r>
+            <a:endParaRPr lang="en-US" sz="800" dirty="0"/>
+          </a:p>
+        </p:txBody>
+      </p:sp>
     </p:spTree>
   </p:cSld>
   <p:clrMapOvr>
@@ -8810,6 +10546,45 @@
           </a:p>
         </p:txBody>
       </p:sp>
+      <p:sp>
+        <p:nvSpPr>
+          <p:cNvPr id="43" name="Text 41"/>
+          <p:cNvSpPr/>
+          <p:nvPr/>
+        </p:nvSpPr>
+        <p:spPr>
+          <a:xfrm>
+            <a:off x="7772400" y="4800600"/>
+            <a:ext cx="1097280" cy="274320"/>
+          </a:xfrm>
+          <a:prstGeom prst="rect">
+            <a:avLst/>
+          </a:prstGeom>
+          <a:noFill/>
+          <a:ln/>
+        </p:spPr>
+        <p:txBody>
+          <a:bodyPr wrap="square" lIns="0" tIns="0" rIns="0" bIns="0" rtlCol="0" anchor="ctr"/>
+          <a:lstStyle/>
+          <a:p>
+            <a:pPr algn="r" indent="0" marL="0">
+              <a:buNone/>
+            </a:pPr>
+            <a:r>
+              <a:rPr lang="en-US" sz="800" dirty="0">
+                <a:solidFill>
+                  <a:srgbClr val="95A5A6"/>
+                </a:solidFill>
+                <a:latin typeface="Calibri" pitchFamily="34" charset="0"/>
+                <a:ea typeface="Calibri" pitchFamily="34" charset="-122"/>
+                <a:cs typeface="Calibri" pitchFamily="34" charset="-120"/>
+              </a:rPr>
+              <a:t>4 / 15</a:t>
+            </a:r>
+            <a:endParaRPr lang="en-US" sz="800" dirty="0"/>
+          </a:p>
+        </p:txBody>
+      </p:sp>
     </p:spTree>
   </p:cSld>
   <p:clrMapOvr>
@@ -9303,6 +11078,45 @@
           </a:p>
         </p:txBody>
       </p:sp>
+      <p:sp>
+        <p:nvSpPr>
+          <p:cNvPr id="10" name="Text 8"/>
+          <p:cNvSpPr/>
+          <p:nvPr/>
+        </p:nvSpPr>
+        <p:spPr>
+          <a:xfrm>
+            <a:off x="7772400" y="4800600"/>
+            <a:ext cx="1097280" cy="274320"/>
+          </a:xfrm>
+          <a:prstGeom prst="rect">
+            <a:avLst/>
+          </a:prstGeom>
+          <a:noFill/>
+          <a:ln/>
+        </p:spPr>
+        <p:txBody>
+          <a:bodyPr wrap="square" lIns="0" tIns="0" rIns="0" bIns="0" rtlCol="0" anchor="ctr"/>
+          <a:lstStyle/>
+          <a:p>
+            <a:pPr algn="r" indent="0" marL="0">
+              <a:buNone/>
+            </a:pPr>
+            <a:r>
+              <a:rPr lang="en-US" sz="800" dirty="0">
+                <a:solidFill>
+                  <a:srgbClr val="95A5A6"/>
+                </a:solidFill>
+                <a:latin typeface="Calibri" pitchFamily="34" charset="0"/>
+                <a:ea typeface="Calibri" pitchFamily="34" charset="-122"/>
+                <a:cs typeface="Calibri" pitchFamily="34" charset="-120"/>
+              </a:rPr>
+              <a:t>5 / 15</a:t>
+            </a:r>
+            <a:endParaRPr lang="en-US" sz="800" dirty="0"/>
+          </a:p>
+        </p:txBody>
+      </p:sp>
     </p:spTree>
   </p:cSld>
   <p:clrMapOvr>
@@ -10414,6 +12228,45 @@
           </a:p>
         </p:txBody>
       </p:sp>
+      <p:sp>
+        <p:nvSpPr>
+          <p:cNvPr id="35" name="Text 26"/>
+          <p:cNvSpPr/>
+          <p:nvPr/>
+        </p:nvSpPr>
+        <p:spPr>
+          <a:xfrm>
+            <a:off x="7772400" y="4800600"/>
+            <a:ext cx="1097280" cy="274320"/>
+          </a:xfrm>
+          <a:prstGeom prst="rect">
+            <a:avLst/>
+          </a:prstGeom>
+          <a:noFill/>
+          <a:ln/>
+        </p:spPr>
+        <p:txBody>
+          <a:bodyPr wrap="square" lIns="0" tIns="0" rIns="0" bIns="0" rtlCol="0" anchor="ctr"/>
+          <a:lstStyle/>
+          <a:p>
+            <a:pPr algn="r" indent="0" marL="0">
+              <a:buNone/>
+            </a:pPr>
+            <a:r>
+              <a:rPr lang="en-US" sz="800" dirty="0">
+                <a:solidFill>
+                  <a:srgbClr val="95A5A6"/>
+                </a:solidFill>
+                <a:latin typeface="Calibri" pitchFamily="34" charset="0"/>
+                <a:ea typeface="Calibri" pitchFamily="34" charset="-122"/>
+                <a:cs typeface="Calibri" pitchFamily="34" charset="-120"/>
+              </a:rPr>
+              <a:t>6 / 15</a:t>
+            </a:r>
+            <a:endParaRPr lang="en-US" sz="800" dirty="0"/>
+          </a:p>
+        </p:txBody>
+      </p:sp>
     </p:spTree>
   </p:cSld>
   <p:clrMapOvr>
@@ -11081,6 +12934,45 @@
           </a:p>
         </p:txBody>
       </p:sp>
+      <p:sp>
+        <p:nvSpPr>
+          <p:cNvPr id="23" name="Text 17"/>
+          <p:cNvSpPr/>
+          <p:nvPr/>
+        </p:nvSpPr>
+        <p:spPr>
+          <a:xfrm>
+            <a:off x="7772400" y="4800600"/>
+            <a:ext cx="1097280" cy="274320"/>
+          </a:xfrm>
+          <a:prstGeom prst="rect">
+            <a:avLst/>
+          </a:prstGeom>
+          <a:noFill/>
+          <a:ln/>
+        </p:spPr>
+        <p:txBody>
+          <a:bodyPr wrap="square" lIns="0" tIns="0" rIns="0" bIns="0" rtlCol="0" anchor="ctr"/>
+          <a:lstStyle/>
+          <a:p>
+            <a:pPr algn="r" indent="0" marL="0">
+              <a:buNone/>
+            </a:pPr>
+            <a:r>
+              <a:rPr lang="en-US" sz="800" dirty="0">
+                <a:solidFill>
+                  <a:srgbClr val="95A5A6"/>
+                </a:solidFill>
+                <a:latin typeface="Calibri" pitchFamily="34" charset="0"/>
+                <a:ea typeface="Calibri" pitchFamily="34" charset="-122"/>
+                <a:cs typeface="Calibri" pitchFamily="34" charset="-120"/>
+              </a:rPr>
+              <a:t>7 / 15</a:t>
+            </a:r>
+            <a:endParaRPr lang="en-US" sz="800" dirty="0"/>
+          </a:p>
+        </p:txBody>
+      </p:sp>
     </p:spTree>
   </p:cSld>
   <p:clrMapOvr>
@@ -11724,6 +13616,45 @@
           </a:p>
         </p:txBody>
       </p:sp>
+      <p:sp>
+        <p:nvSpPr>
+          <p:cNvPr id="12" name="Text 10"/>
+          <p:cNvSpPr/>
+          <p:nvPr/>
+        </p:nvSpPr>
+        <p:spPr>
+          <a:xfrm>
+            <a:off x="7772400" y="4800600"/>
+            <a:ext cx="1097280" cy="274320"/>
+          </a:xfrm>
+          <a:prstGeom prst="rect">
+            <a:avLst/>
+          </a:prstGeom>
+          <a:noFill/>
+          <a:ln/>
+        </p:spPr>
+        <p:txBody>
+          <a:bodyPr wrap="square" lIns="0" tIns="0" rIns="0" bIns="0" rtlCol="0" anchor="ctr"/>
+          <a:lstStyle/>
+          <a:p>
+            <a:pPr algn="r" indent="0" marL="0">
+              <a:buNone/>
+            </a:pPr>
+            <a:r>
+              <a:rPr lang="en-US" sz="800" dirty="0">
+                <a:solidFill>
+                  <a:srgbClr val="95A5A6"/>
+                </a:solidFill>
+                <a:latin typeface="Calibri" pitchFamily="34" charset="0"/>
+                <a:ea typeface="Calibri" pitchFamily="34" charset="-122"/>
+                <a:cs typeface="Calibri" pitchFamily="34" charset="-120"/>
+              </a:rPr>
+              <a:t>8 / 15</a:t>
+            </a:r>
+            <a:endParaRPr lang="en-US" sz="800" dirty="0"/>
+          </a:p>
+        </p:txBody>
+      </p:sp>
     </p:spTree>
   </p:cSld>
   <p:clrMapOvr>
@@ -12686,6 +14617,45 @@
               <a:t>Floor plan + cover sheet + situation plan + compliance report</a:t>
             </a:r>
             <a:endParaRPr lang="en-US" sz="1100" dirty="0"/>
+          </a:p>
+        </p:txBody>
+      </p:sp>
+      <p:sp>
+        <p:nvSpPr>
+          <p:cNvPr id="33" name="Text 25"/>
+          <p:cNvSpPr/>
+          <p:nvPr/>
+        </p:nvSpPr>
+        <p:spPr>
+          <a:xfrm>
+            <a:off x="7772400" y="4800600"/>
+            <a:ext cx="1097280" cy="274320"/>
+          </a:xfrm>
+          <a:prstGeom prst="rect">
+            <a:avLst/>
+          </a:prstGeom>
+          <a:noFill/>
+          <a:ln/>
+        </p:spPr>
+        <p:txBody>
+          <a:bodyPr wrap="square" lIns="0" tIns="0" rIns="0" bIns="0" rtlCol="0" anchor="ctr"/>
+          <a:lstStyle/>
+          <a:p>
+            <a:pPr algn="r" indent="0" marL="0">
+              <a:buNone/>
+            </a:pPr>
+            <a:r>
+              <a:rPr lang="en-US" sz="800" dirty="0">
+                <a:solidFill>
+                  <a:srgbClr val="95A5A6"/>
+                </a:solidFill>
+                <a:latin typeface="Calibri" pitchFamily="34" charset="0"/>
+                <a:ea typeface="Calibri" pitchFamily="34" charset="-122"/>
+                <a:cs typeface="Calibri" pitchFamily="34" charset="-120"/>
+              </a:rPr>
+              <a:t>9 / 15</a:t>
+            </a:r>
+            <a:endParaRPr lang="en-US" sz="800" dirty="0"/>
           </a:p>
         </p:txBody>
       </p:sp>

</xml_diff>